<commit_message>
Use the IIT Delhi crest on the title slide and every header
The crest is square (220x220, transparent), not the wide lockup the
placement code assumed - a contain-fit into a 2:1 box would have
letterboxed it and left the mark floating off-centre. Every placement is
now a 1:1 box: 0.92in on the title and closing slides, 0.58in top-right
on content headers, clear of the corner decoration and the title rule.

Detection now checks docs/ first, so the file works where it was put,
and logs which path it resolved.

QA extended to check logo aspect ratio, edge margins and logo-to-text
collisions. Clean at 18 slides, 18 placements.

Co-Authored-By: Claude Opus 5 <noreply@anthropic.com>
</commit_message>
<xml_diff>
--- a/docs/Graph_of_Thoughts_BTP.pptx
+++ b/docs/Graph_of_Thoughts_BTP.pptx
@@ -3305,87 +3305,33 @@
           </a:ln>
         </p:spPr>
       </p:sp>
-      <p:sp>
-        <p:nvSpPr>
-          <p:cNvPr id="6" name="Text 4"/>
-          <p:cNvSpPr txBox="1"/>
-          <p:nvPr/>
-        </p:nvSpPr>
-        <p:spPr>
-          <a:xfrm>
-            <a:off x="502920" y="219456"/>
-            <a:ext cx="2377440" cy="274320"/>
+      <p:pic>
+        <p:nvPicPr>
+          <p:cNvPr id="6" name="Image 0" descr="D:\SEM7\BTP\docs\IITD-_logo.png">    </p:cNvPr>
+          <p:cNvPicPr>
+            <a:picLocks noChangeAspect="1"/>
+          </p:cNvPicPr>
+          <p:nvPr/>
+        </p:nvPicPr>
+        <p:blipFill>
+          <a:blip r:embed="rId1"/>
+          <a:stretch>
+            <a:fillRect/>
+          </a:stretch>
+        </p:blipFill>
+        <p:spPr>
+          <a:xfrm>
+            <a:off x="530352" y="128016"/>
+            <a:ext cx="841248" cy="841248"/>
           </a:xfrm>
           <a:prstGeom prst="rect">
             <a:avLst/>
           </a:prstGeom>
-          <a:noFill/>
-          <a:ln/>
-        </p:spPr>
-        <p:txBody>
-          <a:bodyPr wrap="square" lIns="0" tIns="0" rIns="0" bIns="0" rtlCol="0" anchor="ctr"/>
-          <a:lstStyle/>
-          <a:p>
-            <a:pPr indent="0" marL="0">
-              <a:buNone/>
-            </a:pPr>
-            <a:r>
-              <a:rPr lang="en-US" sz="1400" b="1" spc="200" kern="0" dirty="0">
-                <a:solidFill>
-                  <a:srgbClr val="23408E"/>
-                </a:solidFill>
-                <a:latin typeface="Montserrat" pitchFamily="34" charset="0"/>
-                <a:ea typeface="Montserrat" pitchFamily="34" charset="-122"/>
-                <a:cs typeface="Montserrat" pitchFamily="34" charset="-120"/>
-              </a:rPr>
-              <a:t>IIT DELHI</a:t>
-            </a:r>
-            <a:endParaRPr lang="en-US" sz="1400" dirty="0"/>
-          </a:p>
-        </p:txBody>
-      </p:sp>
-      <p:sp>
-        <p:nvSpPr>
-          <p:cNvPr id="7" name="Text 5"/>
-          <p:cNvSpPr txBox="1"/>
-          <p:nvPr/>
-        </p:nvSpPr>
-        <p:spPr>
-          <a:xfrm>
-            <a:off x="502920" y="512064"/>
-            <a:ext cx="3108960" cy="237744"/>
-          </a:xfrm>
-          <a:prstGeom prst="rect">
-            <a:avLst/>
-          </a:prstGeom>
-          <a:noFill/>
-          <a:ln/>
-        </p:spPr>
-        <p:txBody>
-          <a:bodyPr wrap="square" lIns="0" tIns="0" rIns="0" bIns="0" rtlCol="0" anchor="ctr"/>
-          <a:lstStyle/>
-          <a:p>
-            <a:pPr indent="0" marL="0">
-              <a:buNone/>
-            </a:pPr>
-            <a:r>
-              <a:rPr lang="en-US" sz="1000" dirty="0">
-                <a:solidFill>
-                  <a:srgbClr val="63697A"/>
-                </a:solidFill>
-                <a:latin typeface="Montserrat" pitchFamily="34" charset="0"/>
-                <a:ea typeface="Montserrat" pitchFamily="34" charset="-122"/>
-                <a:cs typeface="Montserrat" pitchFamily="34" charset="-120"/>
-              </a:rPr>
-              <a:t>Department of Electrical Engineering</a:t>
-            </a:r>
-            <a:endParaRPr lang="en-US" sz="1000" dirty="0"/>
-          </a:p>
-        </p:txBody>
-      </p:sp>
-      <p:sp>
-        <p:nvSpPr>
-          <p:cNvPr id="8" name="Shape 6"/>
+        </p:spPr>
+      </p:pic>
+      <p:sp>
+        <p:nvSpPr>
+          <p:cNvPr id="7" name="Shape 4"/>
           <p:cNvSpPr/>
           <p:nvPr/>
         </p:nvSpPr>
@@ -3412,7 +3358,7 @@
       </p:sp>
       <p:sp>
         <p:nvSpPr>
-          <p:cNvPr id="9" name="Text 7"/>
+          <p:cNvPr id="8" name="Text 5"/>
           <p:cNvSpPr txBox="1"/>
           <p:nvPr/>
         </p:nvSpPr>
@@ -3474,7 +3420,7 @@
       </p:sp>
       <p:sp>
         <p:nvSpPr>
-          <p:cNvPr id="10" name="Text 8"/>
+          <p:cNvPr id="9" name="Text 6"/>
           <p:cNvSpPr txBox="1"/>
           <p:nvPr/>
         </p:nvSpPr>
@@ -3513,7 +3459,7 @@
       </p:sp>
       <p:sp>
         <p:nvSpPr>
-          <p:cNvPr id="11" name="Text 9"/>
+          <p:cNvPr id="10" name="Text 7"/>
           <p:cNvSpPr txBox="1"/>
           <p:nvPr/>
         </p:nvSpPr>
@@ -3552,7 +3498,7 @@
       </p:sp>
       <p:sp>
         <p:nvSpPr>
-          <p:cNvPr id="12" name="Text 10"/>
+          <p:cNvPr id="11" name="Text 8"/>
           <p:cNvSpPr txBox="1"/>
           <p:nvPr/>
         </p:nvSpPr>
@@ -3591,7 +3537,7 @@
       </p:sp>
       <p:sp>
         <p:nvSpPr>
-          <p:cNvPr id="13" name="Text 11"/>
+          <p:cNvPr id="12" name="Text 9"/>
           <p:cNvSpPr txBox="1"/>
           <p:nvPr/>
         </p:nvSpPr>
@@ -3630,7 +3576,7 @@
       </p:sp>
       <p:sp>
         <p:nvSpPr>
-          <p:cNvPr id="14" name="Text 12"/>
+          <p:cNvPr id="13" name="Text 10"/>
           <p:cNvSpPr txBox="1"/>
           <p:nvPr/>
         </p:nvSpPr>
@@ -3807,9 +3753,33 @@
           </a:ln>
         </p:spPr>
       </p:sp>
-      <p:sp>
-        <p:nvSpPr>
-          <p:cNvPr id="6" name="Text 4"/>
+      <p:pic>
+        <p:nvPicPr>
+          <p:cNvPr id="6" name="Image 0" descr="D:\SEM7\BTP\docs\IITD-_logo.png">    </p:cNvPr>
+          <p:cNvPicPr>
+            <a:picLocks noChangeAspect="1"/>
+          </p:cNvPicPr>
+          <p:nvPr/>
+        </p:nvPicPr>
+        <p:blipFill>
+          <a:blip r:embed="rId1"/>
+          <a:stretch>
+            <a:fillRect/>
+          </a:stretch>
+        </p:blipFill>
+        <p:spPr>
+          <a:xfrm>
+            <a:off x="10991088" y="658368"/>
+            <a:ext cx="566928" cy="566928"/>
+          </a:xfrm>
+          <a:prstGeom prst="rect">
+            <a:avLst/>
+          </a:prstGeom>
+        </p:spPr>
+      </p:pic>
+      <p:sp>
+        <p:nvSpPr>
+          <p:cNvPr id="7" name="Text 4"/>
           <p:cNvSpPr txBox="1"/>
           <p:nvPr/>
         </p:nvSpPr>
@@ -3848,7 +3818,7 @@
       </p:sp>
       <p:sp>
         <p:nvSpPr>
-          <p:cNvPr id="7" name="Shape 5"/>
+          <p:cNvPr id="8" name="Shape 5"/>
           <p:cNvSpPr/>
           <p:nvPr/>
         </p:nvSpPr>
@@ -3871,7 +3841,7 @@
       </p:sp>
       <p:sp>
         <p:nvSpPr>
-          <p:cNvPr id="8" name="Shape 6"/>
+          <p:cNvPr id="9" name="Shape 6"/>
           <p:cNvSpPr/>
           <p:nvPr/>
         </p:nvSpPr>
@@ -3896,7 +3866,7 @@
       </p:sp>
       <p:sp>
         <p:nvSpPr>
-          <p:cNvPr id="9" name="Shape 7"/>
+          <p:cNvPr id="10" name="Shape 7"/>
           <p:cNvSpPr/>
           <p:nvPr/>
         </p:nvSpPr>
@@ -3921,7 +3891,7 @@
       </p:sp>
       <p:sp>
         <p:nvSpPr>
-          <p:cNvPr id="10" name="Text 8"/>
+          <p:cNvPr id="11" name="Text 8"/>
           <p:cNvSpPr txBox="1"/>
           <p:nvPr/>
         </p:nvSpPr>
@@ -5362,7 +5332,7 @@
       </p:graphicFrame>
       <p:sp>
         <p:nvSpPr>
-          <p:cNvPr id="12" name="Text 9"/>
+          <p:cNvPr id="13" name="Text 9"/>
           <p:cNvSpPr txBox="1"/>
           <p:nvPr/>
         </p:nvSpPr>
@@ -5401,7 +5371,7 @@
       </p:sp>
       <p:sp>
         <p:nvSpPr>
-          <p:cNvPr id="13" name="Text 10"/>
+          <p:cNvPr id="14" name="Text 10"/>
           <p:cNvSpPr txBox="1"/>
           <p:nvPr/>
         </p:nvSpPr>
@@ -6490,7 +6460,7 @@
       </p:graphicFrame>
       <p:sp>
         <p:nvSpPr>
-          <p:cNvPr id="15" name="Shape 11"/>
+          <p:cNvPr id="16" name="Shape 11"/>
           <p:cNvSpPr/>
           <p:nvPr/>
         </p:nvSpPr>
@@ -6517,7 +6487,7 @@
       </p:sp>
       <p:sp>
         <p:nvSpPr>
-          <p:cNvPr id="16" name="Text 12"/>
+          <p:cNvPr id="17" name="Text 12"/>
           <p:cNvSpPr txBox="1"/>
           <p:nvPr/>
         </p:nvSpPr>
@@ -6556,7 +6526,7 @@
       </p:sp>
       <p:sp>
         <p:nvSpPr>
-          <p:cNvPr id="17" name="Text 13"/>
+          <p:cNvPr id="18" name="Text 13"/>
           <p:cNvSpPr txBox="1"/>
           <p:nvPr/>
         </p:nvSpPr>
@@ -6595,7 +6565,7 @@
       </p:sp>
       <p:sp>
         <p:nvSpPr>
-          <p:cNvPr id="18" name="Text 14"/>
+          <p:cNvPr id="19" name="Text 14"/>
           <p:cNvSpPr txBox="1"/>
           <p:nvPr/>
         </p:nvSpPr>
@@ -6634,7 +6604,7 @@
       </p:sp>
       <p:sp>
         <p:nvSpPr>
-          <p:cNvPr id="19" name="Text 15"/>
+          <p:cNvPr id="20" name="Text 15"/>
           <p:cNvSpPr txBox="1"/>
           <p:nvPr/>
         </p:nvSpPr>
@@ -6673,7 +6643,7 @@
       </p:sp>
       <p:sp>
         <p:nvSpPr>
-          <p:cNvPr id="20" name="Text 16"/>
+          <p:cNvPr id="21" name="Text 16"/>
           <p:cNvSpPr txBox="1"/>
           <p:nvPr/>
         </p:nvSpPr>
@@ -6712,7 +6682,7 @@
       </p:sp>
       <p:sp>
         <p:nvSpPr>
-          <p:cNvPr id="21" name="Text 17"/>
+          <p:cNvPr id="22" name="Text 17"/>
           <p:cNvSpPr txBox="1"/>
           <p:nvPr/>
         </p:nvSpPr>
@@ -6751,7 +6721,7 @@
       </p:sp>
       <p:sp>
         <p:nvSpPr>
-          <p:cNvPr id="22" name="Text 18"/>
+          <p:cNvPr id="23" name="Text 18"/>
           <p:cNvSpPr txBox="1"/>
           <p:nvPr/>
         </p:nvSpPr>
@@ -6790,7 +6760,7 @@
       </p:sp>
       <p:sp>
         <p:nvSpPr>
-          <p:cNvPr id="23" name="Text 19"/>
+          <p:cNvPr id="24" name="Text 19"/>
           <p:cNvSpPr txBox="1"/>
           <p:nvPr/>
         </p:nvSpPr>
@@ -6829,7 +6799,7 @@
       </p:sp>
       <p:sp>
         <p:nvSpPr>
-          <p:cNvPr id="24" name="Text 20"/>
+          <p:cNvPr id="25" name="Text 20"/>
           <p:cNvSpPr txBox="1"/>
           <p:nvPr/>
         </p:nvSpPr>
@@ -7006,9 +6976,33 @@
           </a:ln>
         </p:spPr>
       </p:sp>
-      <p:sp>
-        <p:nvSpPr>
-          <p:cNvPr id="6" name="Text 4"/>
+      <p:pic>
+        <p:nvPicPr>
+          <p:cNvPr id="6" name="Image 0" descr="D:\SEM7\BTP\docs\IITD-_logo.png">    </p:cNvPr>
+          <p:cNvPicPr>
+            <a:picLocks noChangeAspect="1"/>
+          </p:cNvPicPr>
+          <p:nvPr/>
+        </p:nvPicPr>
+        <p:blipFill>
+          <a:blip r:embed="rId1"/>
+          <a:stretch>
+            <a:fillRect/>
+          </a:stretch>
+        </p:blipFill>
+        <p:spPr>
+          <a:xfrm>
+            <a:off x="10991088" y="658368"/>
+            <a:ext cx="566928" cy="566928"/>
+          </a:xfrm>
+          <a:prstGeom prst="rect">
+            <a:avLst/>
+          </a:prstGeom>
+        </p:spPr>
+      </p:pic>
+      <p:sp>
+        <p:nvSpPr>
+          <p:cNvPr id="7" name="Text 4"/>
           <p:cNvSpPr txBox="1"/>
           <p:nvPr/>
         </p:nvSpPr>
@@ -7047,7 +7041,7 @@
       </p:sp>
       <p:sp>
         <p:nvSpPr>
-          <p:cNvPr id="7" name="Shape 5"/>
+          <p:cNvPr id="8" name="Shape 5"/>
           <p:cNvSpPr/>
           <p:nvPr/>
         </p:nvSpPr>
@@ -7070,7 +7064,7 @@
       </p:sp>
       <p:sp>
         <p:nvSpPr>
-          <p:cNvPr id="8" name="Shape 6"/>
+          <p:cNvPr id="9" name="Shape 6"/>
           <p:cNvSpPr/>
           <p:nvPr/>
         </p:nvSpPr>
@@ -7095,7 +7089,7 @@
       </p:sp>
       <p:sp>
         <p:nvSpPr>
-          <p:cNvPr id="9" name="Shape 7"/>
+          <p:cNvPr id="10" name="Shape 7"/>
           <p:cNvSpPr/>
           <p:nvPr/>
         </p:nvSpPr>
@@ -7120,7 +7114,7 @@
       </p:sp>
       <p:sp>
         <p:nvSpPr>
-          <p:cNvPr id="10" name="Text 8"/>
+          <p:cNvPr id="11" name="Text 8"/>
           <p:cNvSpPr txBox="1"/>
           <p:nvPr/>
         </p:nvSpPr>
@@ -8835,7 +8829,7 @@
       </p:graphicFrame>
       <p:sp>
         <p:nvSpPr>
-          <p:cNvPr id="12" name="Text 9"/>
+          <p:cNvPr id="13" name="Text 9"/>
           <p:cNvSpPr txBox="1"/>
           <p:nvPr/>
         </p:nvSpPr>
@@ -8877,7 +8871,7 @@
       </p:sp>
       <p:sp>
         <p:nvSpPr>
-          <p:cNvPr id="13" name="Shape 10"/>
+          <p:cNvPr id="14" name="Shape 10"/>
           <p:cNvSpPr/>
           <p:nvPr/>
         </p:nvSpPr>
@@ -8904,7 +8898,7 @@
       </p:sp>
       <p:sp>
         <p:nvSpPr>
-          <p:cNvPr id="14" name="Text 11"/>
+          <p:cNvPr id="15" name="Text 11"/>
           <p:cNvSpPr txBox="1"/>
           <p:nvPr/>
         </p:nvSpPr>
@@ -8943,7 +8937,7 @@
       </p:sp>
       <p:graphicFrame>
         <p:nvGraphicFramePr>
-          <p:cNvPr id="15" name="Chart 0" descr=""/>
+          <p:cNvPr id="16" name="Chart 0" descr=""/>
           <p:cNvGraphicFramePr/>
           <p:nvPr/>
         </p:nvGraphicFramePr>
@@ -8953,7 +8947,7 @@
         </p:xfrm>
         <a:graphic xmlns:a="http://schemas.openxmlformats.org/drawingml/2006/main">
           <a:graphicData uri="http://schemas.openxmlformats.org/drawingml/2006/chart">
-            <c:chart xmlns:c="http://schemas.openxmlformats.org/drawingml/2006/chart" r:id="rId1"/>
+            <c:chart xmlns:c="http://schemas.openxmlformats.org/drawingml/2006/chart" r:id="rId2"/>
           </a:graphicData>
         </a:graphic>
       </p:graphicFrame>
@@ -9097,9 +9091,33 @@
           </a:ln>
         </p:spPr>
       </p:sp>
-      <p:sp>
-        <p:nvSpPr>
-          <p:cNvPr id="6" name="Text 4"/>
+      <p:pic>
+        <p:nvPicPr>
+          <p:cNvPr id="6" name="Image 0" descr="D:\SEM7\BTP\docs\IITD-_logo.png">    </p:cNvPr>
+          <p:cNvPicPr>
+            <a:picLocks noChangeAspect="1"/>
+          </p:cNvPicPr>
+          <p:nvPr/>
+        </p:nvPicPr>
+        <p:blipFill>
+          <a:blip r:embed="rId1"/>
+          <a:stretch>
+            <a:fillRect/>
+          </a:stretch>
+        </p:blipFill>
+        <p:spPr>
+          <a:xfrm>
+            <a:off x="10991088" y="658368"/>
+            <a:ext cx="566928" cy="566928"/>
+          </a:xfrm>
+          <a:prstGeom prst="rect">
+            <a:avLst/>
+          </a:prstGeom>
+        </p:spPr>
+      </p:pic>
+      <p:sp>
+        <p:nvSpPr>
+          <p:cNvPr id="7" name="Text 4"/>
           <p:cNvSpPr txBox="1"/>
           <p:nvPr/>
         </p:nvSpPr>
@@ -9138,7 +9156,7 @@
       </p:sp>
       <p:sp>
         <p:nvSpPr>
-          <p:cNvPr id="7" name="Shape 5"/>
+          <p:cNvPr id="8" name="Shape 5"/>
           <p:cNvSpPr/>
           <p:nvPr/>
         </p:nvSpPr>
@@ -9161,7 +9179,7 @@
       </p:sp>
       <p:sp>
         <p:nvSpPr>
-          <p:cNvPr id="8" name="Shape 6"/>
+          <p:cNvPr id="9" name="Shape 6"/>
           <p:cNvSpPr/>
           <p:nvPr/>
         </p:nvSpPr>
@@ -9186,7 +9204,7 @@
       </p:sp>
       <p:sp>
         <p:nvSpPr>
-          <p:cNvPr id="9" name="Shape 7"/>
+          <p:cNvPr id="10" name="Shape 7"/>
           <p:cNvSpPr/>
           <p:nvPr/>
         </p:nvSpPr>
@@ -9211,7 +9229,7 @@
       </p:sp>
       <p:sp>
         <p:nvSpPr>
-          <p:cNvPr id="10" name="Text 8"/>
+          <p:cNvPr id="11" name="Text 8"/>
           <p:cNvSpPr txBox="1"/>
           <p:nvPr/>
         </p:nvSpPr>
@@ -9250,7 +9268,7 @@
       </p:sp>
       <p:graphicFrame>
         <p:nvGraphicFramePr>
-          <p:cNvPr id="11" name="Chart 0" descr=""/>
+          <p:cNvPr id="12" name="Chart 0" descr=""/>
           <p:cNvGraphicFramePr/>
           <p:nvPr/>
         </p:nvGraphicFramePr>
@@ -9260,13 +9278,13 @@
         </p:xfrm>
         <a:graphic xmlns:a="http://schemas.openxmlformats.org/drawingml/2006/main">
           <a:graphicData uri="http://schemas.openxmlformats.org/drawingml/2006/chart">
-            <c:chart xmlns:c="http://schemas.openxmlformats.org/drawingml/2006/chart" r:id="rId1"/>
+            <c:chart xmlns:c="http://schemas.openxmlformats.org/drawingml/2006/chart" r:id="rId2"/>
           </a:graphicData>
         </a:graphic>
       </p:graphicFrame>
       <p:sp>
         <p:nvSpPr>
-          <p:cNvPr id="12" name="Text 9"/>
+          <p:cNvPr id="13" name="Text 9"/>
           <p:cNvSpPr txBox="1"/>
           <p:nvPr/>
         </p:nvSpPr>
@@ -9308,7 +9326,7 @@
       </p:sp>
       <p:sp>
         <p:nvSpPr>
-          <p:cNvPr id="13" name="Shape 10"/>
+          <p:cNvPr id="14" name="Shape 10"/>
           <p:cNvSpPr/>
           <p:nvPr/>
         </p:nvSpPr>
@@ -9335,7 +9353,7 @@
       </p:sp>
       <p:sp>
         <p:nvSpPr>
-          <p:cNvPr id="14" name="Text 11"/>
+          <p:cNvPr id="15" name="Text 11"/>
           <p:cNvSpPr txBox="1"/>
           <p:nvPr/>
         </p:nvSpPr>
@@ -9374,7 +9392,7 @@
       </p:sp>
       <p:sp>
         <p:nvSpPr>
-          <p:cNvPr id="15" name="Text 12"/>
+          <p:cNvPr id="16" name="Text 12"/>
           <p:cNvSpPr txBox="1"/>
           <p:nvPr/>
         </p:nvSpPr>
@@ -9413,7 +9431,7 @@
       </p:sp>
       <p:sp>
         <p:nvSpPr>
-          <p:cNvPr id="16" name="Shape 13"/>
+          <p:cNvPr id="17" name="Shape 13"/>
           <p:cNvSpPr/>
           <p:nvPr/>
         </p:nvSpPr>
@@ -9440,7 +9458,7 @@
       </p:sp>
       <p:sp>
         <p:nvSpPr>
-          <p:cNvPr id="17" name="Text 14"/>
+          <p:cNvPr id="18" name="Text 14"/>
           <p:cNvSpPr txBox="1"/>
           <p:nvPr/>
         </p:nvSpPr>
@@ -9479,7 +9497,7 @@
       </p:sp>
       <p:sp>
         <p:nvSpPr>
-          <p:cNvPr id="18" name="Text 15"/>
+          <p:cNvPr id="19" name="Text 15"/>
           <p:cNvSpPr txBox="1"/>
           <p:nvPr/>
         </p:nvSpPr>
@@ -9518,7 +9536,7 @@
       </p:sp>
       <p:sp>
         <p:nvSpPr>
-          <p:cNvPr id="19" name="Text 16"/>
+          <p:cNvPr id="20" name="Text 16"/>
           <p:cNvSpPr txBox="1"/>
           <p:nvPr/>
         </p:nvSpPr>
@@ -9557,7 +9575,7 @@
       </p:sp>
       <p:sp>
         <p:nvSpPr>
-          <p:cNvPr id="20" name="Shape 17"/>
+          <p:cNvPr id="21" name="Shape 17"/>
           <p:cNvSpPr/>
           <p:nvPr/>
         </p:nvSpPr>
@@ -9584,7 +9602,7 @@
       </p:sp>
       <p:sp>
         <p:nvSpPr>
-          <p:cNvPr id="21" name="Text 18"/>
+          <p:cNvPr id="22" name="Text 18"/>
           <p:cNvSpPr txBox="1"/>
           <p:nvPr/>
         </p:nvSpPr>
@@ -9623,7 +9641,7 @@
       </p:sp>
       <p:sp>
         <p:nvSpPr>
-          <p:cNvPr id="22" name="Text 19"/>
+          <p:cNvPr id="23" name="Text 19"/>
           <p:cNvSpPr txBox="1"/>
           <p:nvPr/>
         </p:nvSpPr>
@@ -9800,9 +9818,33 @@
           </a:ln>
         </p:spPr>
       </p:sp>
-      <p:sp>
-        <p:nvSpPr>
-          <p:cNvPr id="6" name="Text 4"/>
+      <p:pic>
+        <p:nvPicPr>
+          <p:cNvPr id="6" name="Image 0" descr="D:\SEM7\BTP\docs\IITD-_logo.png">    </p:cNvPr>
+          <p:cNvPicPr>
+            <a:picLocks noChangeAspect="1"/>
+          </p:cNvPicPr>
+          <p:nvPr/>
+        </p:nvPicPr>
+        <p:blipFill>
+          <a:blip r:embed="rId1"/>
+          <a:stretch>
+            <a:fillRect/>
+          </a:stretch>
+        </p:blipFill>
+        <p:spPr>
+          <a:xfrm>
+            <a:off x="10991088" y="658368"/>
+            <a:ext cx="566928" cy="566928"/>
+          </a:xfrm>
+          <a:prstGeom prst="rect">
+            <a:avLst/>
+          </a:prstGeom>
+        </p:spPr>
+      </p:pic>
+      <p:sp>
+        <p:nvSpPr>
+          <p:cNvPr id="7" name="Text 4"/>
           <p:cNvSpPr txBox="1"/>
           <p:nvPr/>
         </p:nvSpPr>
@@ -9841,7 +9883,7 @@
       </p:sp>
       <p:sp>
         <p:nvSpPr>
-          <p:cNvPr id="7" name="Shape 5"/>
+          <p:cNvPr id="8" name="Shape 5"/>
           <p:cNvSpPr/>
           <p:nvPr/>
         </p:nvSpPr>
@@ -9864,7 +9906,7 @@
       </p:sp>
       <p:sp>
         <p:nvSpPr>
-          <p:cNvPr id="8" name="Shape 6"/>
+          <p:cNvPr id="9" name="Shape 6"/>
           <p:cNvSpPr/>
           <p:nvPr/>
         </p:nvSpPr>
@@ -9889,7 +9931,7 @@
       </p:sp>
       <p:sp>
         <p:nvSpPr>
-          <p:cNvPr id="9" name="Shape 7"/>
+          <p:cNvPr id="10" name="Shape 7"/>
           <p:cNvSpPr/>
           <p:nvPr/>
         </p:nvSpPr>
@@ -9914,7 +9956,7 @@
       </p:sp>
       <p:sp>
         <p:nvSpPr>
-          <p:cNvPr id="10" name="Text 8"/>
+          <p:cNvPr id="11" name="Text 8"/>
           <p:cNvSpPr txBox="1"/>
           <p:nvPr/>
         </p:nvSpPr>
@@ -11355,7 +11397,7 @@
       </p:graphicFrame>
       <p:sp>
         <p:nvSpPr>
-          <p:cNvPr id="12" name="Shape 9"/>
+          <p:cNvPr id="13" name="Shape 9"/>
           <p:cNvSpPr/>
           <p:nvPr/>
         </p:nvSpPr>
@@ -11382,7 +11424,7 @@
       </p:sp>
       <p:sp>
         <p:nvSpPr>
-          <p:cNvPr id="13" name="Text 10"/>
+          <p:cNvPr id="14" name="Text 10"/>
           <p:cNvSpPr txBox="1"/>
           <p:nvPr/>
         </p:nvSpPr>
@@ -11421,7 +11463,7 @@
       </p:sp>
       <p:sp>
         <p:nvSpPr>
-          <p:cNvPr id="14" name="Text 11"/>
+          <p:cNvPr id="15" name="Text 11"/>
           <p:cNvSpPr txBox="1"/>
           <p:nvPr/>
         </p:nvSpPr>
@@ -11463,7 +11505,7 @@
       </p:sp>
       <p:sp>
         <p:nvSpPr>
-          <p:cNvPr id="15" name="Shape 12"/>
+          <p:cNvPr id="16" name="Shape 12"/>
           <p:cNvSpPr/>
           <p:nvPr/>
         </p:nvSpPr>
@@ -11490,7 +11532,7 @@
       </p:sp>
       <p:sp>
         <p:nvSpPr>
-          <p:cNvPr id="16" name="Text 13"/>
+          <p:cNvPr id="17" name="Text 13"/>
           <p:cNvSpPr txBox="1"/>
           <p:nvPr/>
         </p:nvSpPr>
@@ -11529,7 +11571,7 @@
       </p:sp>
       <p:sp>
         <p:nvSpPr>
-          <p:cNvPr id="17" name="Text 14"/>
+          <p:cNvPr id="18" name="Text 14"/>
           <p:cNvSpPr txBox="1"/>
           <p:nvPr/>
         </p:nvSpPr>
@@ -11568,7 +11610,7 @@
       </p:sp>
       <p:sp>
         <p:nvSpPr>
-          <p:cNvPr id="18" name="Shape 15"/>
+          <p:cNvPr id="19" name="Shape 15"/>
           <p:cNvSpPr/>
           <p:nvPr/>
         </p:nvSpPr>
@@ -11595,7 +11637,7 @@
       </p:sp>
       <p:sp>
         <p:nvSpPr>
-          <p:cNvPr id="19" name="Text 16"/>
+          <p:cNvPr id="20" name="Text 16"/>
           <p:cNvSpPr txBox="1"/>
           <p:nvPr/>
         </p:nvSpPr>
@@ -11634,7 +11676,7 @@
       </p:sp>
       <p:sp>
         <p:nvSpPr>
-          <p:cNvPr id="20" name="Text 17"/>
+          <p:cNvPr id="21" name="Text 17"/>
           <p:cNvSpPr txBox="1"/>
           <p:nvPr/>
         </p:nvSpPr>
@@ -11673,7 +11715,7 @@
       </p:sp>
       <p:sp>
         <p:nvSpPr>
-          <p:cNvPr id="21" name="Shape 18"/>
+          <p:cNvPr id="22" name="Shape 18"/>
           <p:cNvSpPr/>
           <p:nvPr/>
         </p:nvSpPr>
@@ -11700,7 +11742,7 @@
       </p:sp>
       <p:sp>
         <p:nvSpPr>
-          <p:cNvPr id="22" name="Text 19"/>
+          <p:cNvPr id="23" name="Text 19"/>
           <p:cNvSpPr txBox="1"/>
           <p:nvPr/>
         </p:nvSpPr>
@@ -11739,7 +11781,7 @@
       </p:sp>
       <p:sp>
         <p:nvSpPr>
-          <p:cNvPr id="23" name="Text 20"/>
+          <p:cNvPr id="24" name="Text 20"/>
           <p:cNvSpPr txBox="1"/>
           <p:nvPr/>
         </p:nvSpPr>
@@ -11778,7 +11820,7 @@
       </p:sp>
       <p:sp>
         <p:nvSpPr>
-          <p:cNvPr id="24" name="Shape 21"/>
+          <p:cNvPr id="25" name="Shape 21"/>
           <p:cNvSpPr/>
           <p:nvPr/>
         </p:nvSpPr>
@@ -11805,7 +11847,7 @@
       </p:sp>
       <p:sp>
         <p:nvSpPr>
-          <p:cNvPr id="25" name="Text 22"/>
+          <p:cNvPr id="26" name="Text 22"/>
           <p:cNvSpPr txBox="1"/>
           <p:nvPr/>
         </p:nvSpPr>
@@ -11844,7 +11886,7 @@
       </p:sp>
       <p:sp>
         <p:nvSpPr>
-          <p:cNvPr id="26" name="Text 23"/>
+          <p:cNvPr id="27" name="Text 23"/>
           <p:cNvSpPr txBox="1"/>
           <p:nvPr/>
         </p:nvSpPr>
@@ -11883,7 +11925,7 @@
       </p:sp>
       <p:sp>
         <p:nvSpPr>
-          <p:cNvPr id="27" name="Shape 24"/>
+          <p:cNvPr id="28" name="Shape 24"/>
           <p:cNvSpPr/>
           <p:nvPr/>
         </p:nvSpPr>
@@ -11910,7 +11952,7 @@
       </p:sp>
       <p:sp>
         <p:nvSpPr>
-          <p:cNvPr id="28" name="Text 25"/>
+          <p:cNvPr id="29" name="Text 25"/>
           <p:cNvSpPr txBox="1"/>
           <p:nvPr/>
         </p:nvSpPr>
@@ -11949,7 +11991,7 @@
       </p:sp>
       <p:sp>
         <p:nvSpPr>
-          <p:cNvPr id="29" name="Text 26"/>
+          <p:cNvPr id="30" name="Text 26"/>
           <p:cNvSpPr txBox="1"/>
           <p:nvPr/>
         </p:nvSpPr>
@@ -12126,9 +12168,33 @@
           </a:ln>
         </p:spPr>
       </p:sp>
-      <p:sp>
-        <p:nvSpPr>
-          <p:cNvPr id="6" name="Text 4"/>
+      <p:pic>
+        <p:nvPicPr>
+          <p:cNvPr id="6" name="Image 0" descr="D:\SEM7\BTP\docs\IITD-_logo.png">    </p:cNvPr>
+          <p:cNvPicPr>
+            <a:picLocks noChangeAspect="1"/>
+          </p:cNvPicPr>
+          <p:nvPr/>
+        </p:nvPicPr>
+        <p:blipFill>
+          <a:blip r:embed="rId1"/>
+          <a:stretch>
+            <a:fillRect/>
+          </a:stretch>
+        </p:blipFill>
+        <p:spPr>
+          <a:xfrm>
+            <a:off x="10991088" y="658368"/>
+            <a:ext cx="566928" cy="566928"/>
+          </a:xfrm>
+          <a:prstGeom prst="rect">
+            <a:avLst/>
+          </a:prstGeom>
+        </p:spPr>
+      </p:pic>
+      <p:sp>
+        <p:nvSpPr>
+          <p:cNvPr id="7" name="Text 4"/>
           <p:cNvSpPr txBox="1"/>
           <p:nvPr/>
         </p:nvSpPr>
@@ -12167,7 +12233,7 @@
       </p:sp>
       <p:sp>
         <p:nvSpPr>
-          <p:cNvPr id="7" name="Shape 5"/>
+          <p:cNvPr id="8" name="Shape 5"/>
           <p:cNvSpPr/>
           <p:nvPr/>
         </p:nvSpPr>
@@ -12190,7 +12256,7 @@
       </p:sp>
       <p:sp>
         <p:nvSpPr>
-          <p:cNvPr id="8" name="Shape 6"/>
+          <p:cNvPr id="9" name="Shape 6"/>
           <p:cNvSpPr/>
           <p:nvPr/>
         </p:nvSpPr>
@@ -12215,7 +12281,7 @@
       </p:sp>
       <p:sp>
         <p:nvSpPr>
-          <p:cNvPr id="9" name="Shape 7"/>
+          <p:cNvPr id="10" name="Shape 7"/>
           <p:cNvSpPr/>
           <p:nvPr/>
         </p:nvSpPr>
@@ -12240,7 +12306,7 @@
       </p:sp>
       <p:sp>
         <p:nvSpPr>
-          <p:cNvPr id="10" name="Text 8"/>
+          <p:cNvPr id="11" name="Text 8"/>
           <p:cNvSpPr txBox="1"/>
           <p:nvPr/>
         </p:nvSpPr>
@@ -12279,7 +12345,7 @@
       </p:sp>
       <p:sp>
         <p:nvSpPr>
-          <p:cNvPr id="11" name="Shape 9"/>
+          <p:cNvPr id="12" name="Shape 9"/>
           <p:cNvSpPr/>
           <p:nvPr/>
         </p:nvSpPr>
@@ -12306,7 +12372,7 @@
       </p:sp>
       <p:sp>
         <p:nvSpPr>
-          <p:cNvPr id="12" name="Text 10"/>
+          <p:cNvPr id="13" name="Text 10"/>
           <p:cNvSpPr txBox="1"/>
           <p:nvPr/>
         </p:nvSpPr>
@@ -12345,7 +12411,7 @@
       </p:sp>
       <p:sp>
         <p:nvSpPr>
-          <p:cNvPr id="13" name="Text 11"/>
+          <p:cNvPr id="14" name="Text 11"/>
           <p:cNvSpPr txBox="1"/>
           <p:nvPr/>
         </p:nvSpPr>
@@ -12384,7 +12450,7 @@
       </p:sp>
       <p:sp>
         <p:nvSpPr>
-          <p:cNvPr id="14" name="Text 12"/>
+          <p:cNvPr id="15" name="Text 12"/>
           <p:cNvSpPr txBox="1"/>
           <p:nvPr/>
         </p:nvSpPr>
@@ -12423,7 +12489,7 @@
       </p:sp>
       <p:sp>
         <p:nvSpPr>
-          <p:cNvPr id="15" name="Shape 13"/>
+          <p:cNvPr id="16" name="Shape 13"/>
           <p:cNvSpPr/>
           <p:nvPr/>
         </p:nvSpPr>
@@ -12450,7 +12516,7 @@
       </p:sp>
       <p:sp>
         <p:nvSpPr>
-          <p:cNvPr id="16" name="Text 14"/>
+          <p:cNvPr id="17" name="Text 14"/>
           <p:cNvSpPr txBox="1"/>
           <p:nvPr/>
         </p:nvSpPr>
@@ -12489,7 +12555,7 @@
       </p:sp>
       <p:sp>
         <p:nvSpPr>
-          <p:cNvPr id="17" name="Text 15"/>
+          <p:cNvPr id="18" name="Text 15"/>
           <p:cNvSpPr txBox="1"/>
           <p:nvPr/>
         </p:nvSpPr>
@@ -12528,7 +12594,7 @@
       </p:sp>
       <p:sp>
         <p:nvSpPr>
-          <p:cNvPr id="18" name="Text 16"/>
+          <p:cNvPr id="19" name="Text 16"/>
           <p:cNvSpPr txBox="1"/>
           <p:nvPr/>
         </p:nvSpPr>
@@ -12567,7 +12633,7 @@
       </p:sp>
       <p:sp>
         <p:nvSpPr>
-          <p:cNvPr id="19" name="Shape 17"/>
+          <p:cNvPr id="20" name="Shape 17"/>
           <p:cNvSpPr/>
           <p:nvPr/>
         </p:nvSpPr>
@@ -12594,7 +12660,7 @@
       </p:sp>
       <p:sp>
         <p:nvSpPr>
-          <p:cNvPr id="20" name="Text 18"/>
+          <p:cNvPr id="21" name="Text 18"/>
           <p:cNvSpPr txBox="1"/>
           <p:nvPr/>
         </p:nvSpPr>
@@ -12633,7 +12699,7 @@
       </p:sp>
       <p:sp>
         <p:nvSpPr>
-          <p:cNvPr id="21" name="Shape 19"/>
+          <p:cNvPr id="22" name="Shape 19"/>
           <p:cNvSpPr/>
           <p:nvPr/>
         </p:nvSpPr>
@@ -12658,7 +12724,7 @@
       </p:sp>
       <p:sp>
         <p:nvSpPr>
-          <p:cNvPr id="22" name="Text 20"/>
+          <p:cNvPr id="23" name="Text 20"/>
           <p:cNvSpPr txBox="1"/>
           <p:nvPr/>
         </p:nvSpPr>
@@ -12697,7 +12763,7 @@
       </p:sp>
       <p:sp>
         <p:nvSpPr>
-          <p:cNvPr id="23" name="Text 21"/>
+          <p:cNvPr id="24" name="Text 21"/>
           <p:cNvSpPr txBox="1"/>
           <p:nvPr/>
         </p:nvSpPr>
@@ -12736,7 +12802,7 @@
       </p:sp>
       <p:sp>
         <p:nvSpPr>
-          <p:cNvPr id="24" name="Shape 22"/>
+          <p:cNvPr id="25" name="Shape 22"/>
           <p:cNvSpPr/>
           <p:nvPr/>
         </p:nvSpPr>
@@ -12761,7 +12827,7 @@
       </p:sp>
       <p:sp>
         <p:nvSpPr>
-          <p:cNvPr id="25" name="Text 23"/>
+          <p:cNvPr id="26" name="Text 23"/>
           <p:cNvSpPr txBox="1"/>
           <p:nvPr/>
         </p:nvSpPr>
@@ -12800,7 +12866,7 @@
       </p:sp>
       <p:sp>
         <p:nvSpPr>
-          <p:cNvPr id="26" name="Text 24"/>
+          <p:cNvPr id="27" name="Text 24"/>
           <p:cNvSpPr txBox="1"/>
           <p:nvPr/>
         </p:nvSpPr>
@@ -12839,7 +12905,7 @@
       </p:sp>
       <p:sp>
         <p:nvSpPr>
-          <p:cNvPr id="27" name="Shape 25"/>
+          <p:cNvPr id="28" name="Shape 25"/>
           <p:cNvSpPr/>
           <p:nvPr/>
         </p:nvSpPr>
@@ -12864,7 +12930,7 @@
       </p:sp>
       <p:sp>
         <p:nvSpPr>
-          <p:cNvPr id="28" name="Text 26"/>
+          <p:cNvPr id="29" name="Text 26"/>
           <p:cNvSpPr txBox="1"/>
           <p:nvPr/>
         </p:nvSpPr>
@@ -12903,7 +12969,7 @@
       </p:sp>
       <p:sp>
         <p:nvSpPr>
-          <p:cNvPr id="29" name="Text 27"/>
+          <p:cNvPr id="30" name="Text 27"/>
           <p:cNvSpPr txBox="1"/>
           <p:nvPr/>
         </p:nvSpPr>
@@ -12942,7 +13008,7 @@
       </p:sp>
       <p:sp>
         <p:nvSpPr>
-          <p:cNvPr id="30" name="Shape 28"/>
+          <p:cNvPr id="31" name="Shape 28"/>
           <p:cNvSpPr/>
           <p:nvPr/>
         </p:nvSpPr>
@@ -12969,7 +13035,7 @@
       </p:sp>
       <p:sp>
         <p:nvSpPr>
-          <p:cNvPr id="31" name="Text 29"/>
+          <p:cNvPr id="32" name="Text 29"/>
           <p:cNvSpPr txBox="1"/>
           <p:nvPr/>
         </p:nvSpPr>
@@ -13146,9 +13212,33 @@
           </a:ln>
         </p:spPr>
       </p:sp>
-      <p:sp>
-        <p:nvSpPr>
-          <p:cNvPr id="6" name="Text 4"/>
+      <p:pic>
+        <p:nvPicPr>
+          <p:cNvPr id="6" name="Image 0" descr="D:\SEM7\BTP\docs\IITD-_logo.png">    </p:cNvPr>
+          <p:cNvPicPr>
+            <a:picLocks noChangeAspect="1"/>
+          </p:cNvPicPr>
+          <p:nvPr/>
+        </p:nvPicPr>
+        <p:blipFill>
+          <a:blip r:embed="rId1"/>
+          <a:stretch>
+            <a:fillRect/>
+          </a:stretch>
+        </p:blipFill>
+        <p:spPr>
+          <a:xfrm>
+            <a:off x="10991088" y="658368"/>
+            <a:ext cx="566928" cy="566928"/>
+          </a:xfrm>
+          <a:prstGeom prst="rect">
+            <a:avLst/>
+          </a:prstGeom>
+        </p:spPr>
+      </p:pic>
+      <p:sp>
+        <p:nvSpPr>
+          <p:cNvPr id="7" name="Text 4"/>
           <p:cNvSpPr txBox="1"/>
           <p:nvPr/>
         </p:nvSpPr>
@@ -13187,7 +13277,7 @@
       </p:sp>
       <p:sp>
         <p:nvSpPr>
-          <p:cNvPr id="7" name="Shape 5"/>
+          <p:cNvPr id="8" name="Shape 5"/>
           <p:cNvSpPr/>
           <p:nvPr/>
         </p:nvSpPr>
@@ -13210,7 +13300,7 @@
       </p:sp>
       <p:sp>
         <p:nvSpPr>
-          <p:cNvPr id="8" name="Shape 6"/>
+          <p:cNvPr id="9" name="Shape 6"/>
           <p:cNvSpPr/>
           <p:nvPr/>
         </p:nvSpPr>
@@ -13235,7 +13325,7 @@
       </p:sp>
       <p:sp>
         <p:nvSpPr>
-          <p:cNvPr id="9" name="Shape 7"/>
+          <p:cNvPr id="10" name="Shape 7"/>
           <p:cNvSpPr/>
           <p:nvPr/>
         </p:nvSpPr>
@@ -13260,7 +13350,7 @@
       </p:sp>
       <p:sp>
         <p:nvSpPr>
-          <p:cNvPr id="10" name="Text 8"/>
+          <p:cNvPr id="11" name="Text 8"/>
           <p:cNvSpPr txBox="1"/>
           <p:nvPr/>
         </p:nvSpPr>
@@ -14360,7 +14450,7 @@
       </p:graphicFrame>
       <p:sp>
         <p:nvSpPr>
-          <p:cNvPr id="12" name="Shape 9"/>
+          <p:cNvPr id="13" name="Shape 9"/>
           <p:cNvSpPr/>
           <p:nvPr/>
         </p:nvSpPr>
@@ -14387,7 +14477,7 @@
       </p:sp>
       <p:sp>
         <p:nvSpPr>
-          <p:cNvPr id="13" name="Text 10"/>
+          <p:cNvPr id="14" name="Text 10"/>
           <p:cNvSpPr txBox="1"/>
           <p:nvPr/>
         </p:nvSpPr>
@@ -14426,7 +14516,7 @@
       </p:sp>
       <p:sp>
         <p:nvSpPr>
-          <p:cNvPr id="14" name="Shape 11"/>
+          <p:cNvPr id="15" name="Shape 11"/>
           <p:cNvSpPr/>
           <p:nvPr/>
         </p:nvSpPr>
@@ -14453,7 +14543,7 @@
       </p:sp>
       <p:sp>
         <p:nvSpPr>
-          <p:cNvPr id="15" name="Text 12"/>
+          <p:cNvPr id="16" name="Text 12"/>
           <p:cNvSpPr txBox="1"/>
           <p:nvPr/>
         </p:nvSpPr>
@@ -14492,7 +14582,7 @@
       </p:sp>
       <p:sp>
         <p:nvSpPr>
-          <p:cNvPr id="16" name="Shape 13"/>
+          <p:cNvPr id="17" name="Shape 13"/>
           <p:cNvSpPr/>
           <p:nvPr/>
         </p:nvSpPr>
@@ -14517,7 +14607,7 @@
       </p:sp>
       <p:sp>
         <p:nvSpPr>
-          <p:cNvPr id="17" name="Text 14"/>
+          <p:cNvPr id="18" name="Text 14"/>
           <p:cNvSpPr txBox="1"/>
           <p:nvPr/>
         </p:nvSpPr>
@@ -14556,7 +14646,7 @@
       </p:sp>
       <p:sp>
         <p:nvSpPr>
-          <p:cNvPr id="18" name="Text 15"/>
+          <p:cNvPr id="19" name="Text 15"/>
           <p:cNvSpPr txBox="1"/>
           <p:nvPr/>
         </p:nvSpPr>
@@ -14595,7 +14685,7 @@
       </p:sp>
       <p:sp>
         <p:nvSpPr>
-          <p:cNvPr id="19" name="Shape 16"/>
+          <p:cNvPr id="20" name="Shape 16"/>
           <p:cNvSpPr/>
           <p:nvPr/>
         </p:nvSpPr>
@@ -14620,7 +14710,7 @@
       </p:sp>
       <p:sp>
         <p:nvSpPr>
-          <p:cNvPr id="20" name="Text 17"/>
+          <p:cNvPr id="21" name="Text 17"/>
           <p:cNvSpPr txBox="1"/>
           <p:nvPr/>
         </p:nvSpPr>
@@ -14659,7 +14749,7 @@
       </p:sp>
       <p:sp>
         <p:nvSpPr>
-          <p:cNvPr id="21" name="Text 18"/>
+          <p:cNvPr id="22" name="Text 18"/>
           <p:cNvSpPr txBox="1"/>
           <p:nvPr/>
         </p:nvSpPr>
@@ -14698,7 +14788,7 @@
       </p:sp>
       <p:sp>
         <p:nvSpPr>
-          <p:cNvPr id="22" name="Shape 19"/>
+          <p:cNvPr id="23" name="Shape 19"/>
           <p:cNvSpPr/>
           <p:nvPr/>
         </p:nvSpPr>
@@ -14723,7 +14813,7 @@
       </p:sp>
       <p:sp>
         <p:nvSpPr>
-          <p:cNvPr id="23" name="Text 20"/>
+          <p:cNvPr id="24" name="Text 20"/>
           <p:cNvSpPr txBox="1"/>
           <p:nvPr/>
         </p:nvSpPr>
@@ -14762,7 +14852,7 @@
       </p:sp>
       <p:sp>
         <p:nvSpPr>
-          <p:cNvPr id="24" name="Text 21"/>
+          <p:cNvPr id="25" name="Text 21"/>
           <p:cNvSpPr txBox="1"/>
           <p:nvPr/>
         </p:nvSpPr>
@@ -14801,7 +14891,7 @@
       </p:sp>
       <p:sp>
         <p:nvSpPr>
-          <p:cNvPr id="25" name="Shape 22"/>
+          <p:cNvPr id="26" name="Shape 22"/>
           <p:cNvSpPr/>
           <p:nvPr/>
         </p:nvSpPr>
@@ -14826,7 +14916,7 @@
       </p:sp>
       <p:sp>
         <p:nvSpPr>
-          <p:cNvPr id="26" name="Text 23"/>
+          <p:cNvPr id="27" name="Text 23"/>
           <p:cNvSpPr txBox="1"/>
           <p:nvPr/>
         </p:nvSpPr>
@@ -14865,7 +14955,7 @@
       </p:sp>
       <p:sp>
         <p:nvSpPr>
-          <p:cNvPr id="27" name="Text 24"/>
+          <p:cNvPr id="28" name="Text 24"/>
           <p:cNvSpPr txBox="1"/>
           <p:nvPr/>
         </p:nvSpPr>
@@ -14904,7 +14994,7 @@
       </p:sp>
       <p:sp>
         <p:nvSpPr>
-          <p:cNvPr id="28" name="Shape 25"/>
+          <p:cNvPr id="29" name="Shape 25"/>
           <p:cNvSpPr/>
           <p:nvPr/>
         </p:nvSpPr>
@@ -14929,7 +15019,7 @@
       </p:sp>
       <p:sp>
         <p:nvSpPr>
-          <p:cNvPr id="29" name="Text 26"/>
+          <p:cNvPr id="30" name="Text 26"/>
           <p:cNvSpPr txBox="1"/>
           <p:nvPr/>
         </p:nvSpPr>
@@ -14968,7 +15058,7 @@
       </p:sp>
       <p:sp>
         <p:nvSpPr>
-          <p:cNvPr id="30" name="Text 27"/>
+          <p:cNvPr id="31" name="Text 27"/>
           <p:cNvSpPr txBox="1"/>
           <p:nvPr/>
         </p:nvSpPr>
@@ -15007,7 +15097,7 @@
       </p:sp>
       <p:sp>
         <p:nvSpPr>
-          <p:cNvPr id="31" name="Shape 28"/>
+          <p:cNvPr id="32" name="Shape 28"/>
           <p:cNvSpPr/>
           <p:nvPr/>
         </p:nvSpPr>
@@ -15034,7 +15124,7 @@
       </p:sp>
       <p:sp>
         <p:nvSpPr>
-          <p:cNvPr id="32" name="Text 29"/>
+          <p:cNvPr id="33" name="Text 29"/>
           <p:cNvSpPr txBox="1"/>
           <p:nvPr/>
         </p:nvSpPr>
@@ -15211,9 +15301,33 @@
           </a:ln>
         </p:spPr>
       </p:sp>
-      <p:sp>
-        <p:nvSpPr>
-          <p:cNvPr id="6" name="Text 4"/>
+      <p:pic>
+        <p:nvPicPr>
+          <p:cNvPr id="6" name="Image 0" descr="D:\SEM7\BTP\docs\IITD-_logo.png">    </p:cNvPr>
+          <p:cNvPicPr>
+            <a:picLocks noChangeAspect="1"/>
+          </p:cNvPicPr>
+          <p:nvPr/>
+        </p:nvPicPr>
+        <p:blipFill>
+          <a:blip r:embed="rId1"/>
+          <a:stretch>
+            <a:fillRect/>
+          </a:stretch>
+        </p:blipFill>
+        <p:spPr>
+          <a:xfrm>
+            <a:off x="10991088" y="658368"/>
+            <a:ext cx="566928" cy="566928"/>
+          </a:xfrm>
+          <a:prstGeom prst="rect">
+            <a:avLst/>
+          </a:prstGeom>
+        </p:spPr>
+      </p:pic>
+      <p:sp>
+        <p:nvSpPr>
+          <p:cNvPr id="7" name="Text 4"/>
           <p:cNvSpPr txBox="1"/>
           <p:nvPr/>
         </p:nvSpPr>
@@ -15252,7 +15366,7 @@
       </p:sp>
       <p:sp>
         <p:nvSpPr>
-          <p:cNvPr id="7" name="Shape 5"/>
+          <p:cNvPr id="8" name="Shape 5"/>
           <p:cNvSpPr/>
           <p:nvPr/>
         </p:nvSpPr>
@@ -15275,7 +15389,7 @@
       </p:sp>
       <p:sp>
         <p:nvSpPr>
-          <p:cNvPr id="8" name="Shape 6"/>
+          <p:cNvPr id="9" name="Shape 6"/>
           <p:cNvSpPr/>
           <p:nvPr/>
         </p:nvSpPr>
@@ -15300,7 +15414,7 @@
       </p:sp>
       <p:sp>
         <p:nvSpPr>
-          <p:cNvPr id="9" name="Shape 7"/>
+          <p:cNvPr id="10" name="Shape 7"/>
           <p:cNvSpPr/>
           <p:nvPr/>
         </p:nvSpPr>
@@ -15325,7 +15439,7 @@
       </p:sp>
       <p:sp>
         <p:nvSpPr>
-          <p:cNvPr id="10" name="Text 8"/>
+          <p:cNvPr id="11" name="Text 8"/>
           <p:cNvSpPr txBox="1"/>
           <p:nvPr/>
         </p:nvSpPr>
@@ -15491,7 +15605,7 @@
       </p:sp>
       <p:sp>
         <p:nvSpPr>
-          <p:cNvPr id="11" name="Shape 9"/>
+          <p:cNvPr id="12" name="Shape 9"/>
           <p:cNvSpPr/>
           <p:nvPr/>
         </p:nvSpPr>
@@ -15518,7 +15632,7 @@
       </p:sp>
       <p:sp>
         <p:nvSpPr>
-          <p:cNvPr id="12" name="Text 10"/>
+          <p:cNvPr id="13" name="Text 10"/>
           <p:cNvSpPr txBox="1"/>
           <p:nvPr/>
         </p:nvSpPr>
@@ -15557,7 +15671,7 @@
       </p:sp>
       <p:sp>
         <p:nvSpPr>
-          <p:cNvPr id="13" name="Text 11"/>
+          <p:cNvPr id="14" name="Text 11"/>
           <p:cNvSpPr txBox="1"/>
           <p:nvPr/>
         </p:nvSpPr>
@@ -15596,7 +15710,7 @@
       </p:sp>
       <p:sp>
         <p:nvSpPr>
-          <p:cNvPr id="14" name="Text 12"/>
+          <p:cNvPr id="15" name="Text 12"/>
           <p:cNvSpPr txBox="1"/>
           <p:nvPr/>
         </p:nvSpPr>
@@ -15635,7 +15749,7 @@
       </p:sp>
       <p:sp>
         <p:nvSpPr>
-          <p:cNvPr id="15" name="Text 13"/>
+          <p:cNvPr id="16" name="Text 13"/>
           <p:cNvSpPr txBox="1"/>
           <p:nvPr/>
         </p:nvSpPr>
@@ -15674,7 +15788,7 @@
       </p:sp>
       <p:sp>
         <p:nvSpPr>
-          <p:cNvPr id="16" name="Text 14"/>
+          <p:cNvPr id="17" name="Text 14"/>
           <p:cNvSpPr txBox="1"/>
           <p:nvPr/>
         </p:nvSpPr>
@@ -15713,7 +15827,7 @@
       </p:sp>
       <p:sp>
         <p:nvSpPr>
-          <p:cNvPr id="17" name="Text 15"/>
+          <p:cNvPr id="18" name="Text 15"/>
           <p:cNvSpPr txBox="1"/>
           <p:nvPr/>
         </p:nvSpPr>
@@ -15752,7 +15866,7 @@
       </p:sp>
       <p:sp>
         <p:nvSpPr>
-          <p:cNvPr id="18" name="Text 16"/>
+          <p:cNvPr id="19" name="Text 16"/>
           <p:cNvSpPr txBox="1"/>
           <p:nvPr/>
         </p:nvSpPr>
@@ -15929,9 +16043,33 @@
           </a:ln>
         </p:spPr>
       </p:sp>
-      <p:sp>
-        <p:nvSpPr>
-          <p:cNvPr id="6" name="Text 4"/>
+      <p:pic>
+        <p:nvPicPr>
+          <p:cNvPr id="6" name="Image 0" descr="D:\SEM7\BTP\docs\IITD-_logo.png">    </p:cNvPr>
+          <p:cNvPicPr>
+            <a:picLocks noChangeAspect="1"/>
+          </p:cNvPicPr>
+          <p:nvPr/>
+        </p:nvPicPr>
+        <p:blipFill>
+          <a:blip r:embed="rId1"/>
+          <a:stretch>
+            <a:fillRect/>
+          </a:stretch>
+        </p:blipFill>
+        <p:spPr>
+          <a:xfrm>
+            <a:off x="10991088" y="658368"/>
+            <a:ext cx="566928" cy="566928"/>
+          </a:xfrm>
+          <a:prstGeom prst="rect">
+            <a:avLst/>
+          </a:prstGeom>
+        </p:spPr>
+      </p:pic>
+      <p:sp>
+        <p:nvSpPr>
+          <p:cNvPr id="7" name="Text 4"/>
           <p:cNvSpPr txBox="1"/>
           <p:nvPr/>
         </p:nvSpPr>
@@ -15970,7 +16108,7 @@
       </p:sp>
       <p:sp>
         <p:nvSpPr>
-          <p:cNvPr id="7" name="Shape 5"/>
+          <p:cNvPr id="8" name="Shape 5"/>
           <p:cNvSpPr/>
           <p:nvPr/>
         </p:nvSpPr>
@@ -15993,7 +16131,7 @@
       </p:sp>
       <p:sp>
         <p:nvSpPr>
-          <p:cNvPr id="8" name="Shape 6"/>
+          <p:cNvPr id="9" name="Shape 6"/>
           <p:cNvSpPr/>
           <p:nvPr/>
         </p:nvSpPr>
@@ -16018,7 +16156,7 @@
       </p:sp>
       <p:sp>
         <p:nvSpPr>
-          <p:cNvPr id="9" name="Shape 7"/>
+          <p:cNvPr id="10" name="Shape 7"/>
           <p:cNvSpPr/>
           <p:nvPr/>
         </p:nvSpPr>
@@ -16043,7 +16181,7 @@
       </p:sp>
       <p:sp>
         <p:nvSpPr>
-          <p:cNvPr id="10" name="Text 8"/>
+          <p:cNvPr id="11" name="Text 8"/>
           <p:cNvSpPr txBox="1"/>
           <p:nvPr/>
         </p:nvSpPr>
@@ -16085,7 +16223,7 @@
       </p:sp>
       <p:sp>
         <p:nvSpPr>
-          <p:cNvPr id="11" name="Text 9"/>
+          <p:cNvPr id="12" name="Text 9"/>
           <p:cNvSpPr txBox="1"/>
           <p:nvPr/>
         </p:nvSpPr>
@@ -16127,7 +16265,7 @@
       </p:sp>
       <p:sp>
         <p:nvSpPr>
-          <p:cNvPr id="12" name="Text 10"/>
+          <p:cNvPr id="13" name="Text 10"/>
           <p:cNvSpPr txBox="1"/>
           <p:nvPr/>
         </p:nvSpPr>
@@ -16169,7 +16307,7 @@
       </p:sp>
       <p:sp>
         <p:nvSpPr>
-          <p:cNvPr id="13" name="Text 11"/>
+          <p:cNvPr id="14" name="Text 11"/>
           <p:cNvSpPr txBox="1"/>
           <p:nvPr/>
         </p:nvSpPr>
@@ -16211,7 +16349,7 @@
       </p:sp>
       <p:sp>
         <p:nvSpPr>
-          <p:cNvPr id="14" name="Text 12"/>
+          <p:cNvPr id="15" name="Text 12"/>
           <p:cNvSpPr txBox="1"/>
           <p:nvPr/>
         </p:nvSpPr>
@@ -16253,7 +16391,7 @@
       </p:sp>
       <p:sp>
         <p:nvSpPr>
-          <p:cNvPr id="15" name="Text 13"/>
+          <p:cNvPr id="16" name="Text 13"/>
           <p:cNvSpPr txBox="1"/>
           <p:nvPr/>
         </p:nvSpPr>
@@ -16295,7 +16433,7 @@
       </p:sp>
       <p:sp>
         <p:nvSpPr>
-          <p:cNvPr id="16" name="Text 14"/>
+          <p:cNvPr id="17" name="Text 14"/>
           <p:cNvSpPr txBox="1"/>
           <p:nvPr/>
         </p:nvSpPr>
@@ -16337,7 +16475,7 @@
       </p:sp>
       <p:sp>
         <p:nvSpPr>
-          <p:cNvPr id="17" name="Text 15"/>
+          <p:cNvPr id="18" name="Text 15"/>
           <p:cNvSpPr txBox="1"/>
           <p:nvPr/>
         </p:nvSpPr>
@@ -16379,7 +16517,7 @@
       </p:sp>
       <p:sp>
         <p:nvSpPr>
-          <p:cNvPr id="18" name="Text 16"/>
+          <p:cNvPr id="19" name="Text 16"/>
           <p:cNvSpPr txBox="1"/>
           <p:nvPr/>
         </p:nvSpPr>
@@ -16559,87 +16697,33 @@
           </a:ln>
         </p:spPr>
       </p:sp>
-      <p:sp>
-        <p:nvSpPr>
-          <p:cNvPr id="6" name="Text 4"/>
-          <p:cNvSpPr txBox="1"/>
-          <p:nvPr/>
-        </p:nvSpPr>
-        <p:spPr>
-          <a:xfrm>
-            <a:off x="502920" y="219456"/>
-            <a:ext cx="2377440" cy="274320"/>
+      <p:pic>
+        <p:nvPicPr>
+          <p:cNvPr id="6" name="Image 0" descr="D:\SEM7\BTP\docs\IITD-_logo.png">    </p:cNvPr>
+          <p:cNvPicPr>
+            <a:picLocks noChangeAspect="1"/>
+          </p:cNvPicPr>
+          <p:nvPr/>
+        </p:nvPicPr>
+        <p:blipFill>
+          <a:blip r:embed="rId1"/>
+          <a:stretch>
+            <a:fillRect/>
+          </a:stretch>
+        </p:blipFill>
+        <p:spPr>
+          <a:xfrm>
+            <a:off x="530352" y="128016"/>
+            <a:ext cx="841248" cy="841248"/>
           </a:xfrm>
           <a:prstGeom prst="rect">
             <a:avLst/>
           </a:prstGeom>
-          <a:noFill/>
-          <a:ln/>
-        </p:spPr>
-        <p:txBody>
-          <a:bodyPr wrap="square" lIns="0" tIns="0" rIns="0" bIns="0" rtlCol="0" anchor="ctr"/>
-          <a:lstStyle/>
-          <a:p>
-            <a:pPr indent="0" marL="0">
-              <a:buNone/>
-            </a:pPr>
-            <a:r>
-              <a:rPr lang="en-US" sz="1400" b="1" spc="200" kern="0" dirty="0">
-                <a:solidFill>
-                  <a:srgbClr val="23408E"/>
-                </a:solidFill>
-                <a:latin typeface="Montserrat" pitchFamily="34" charset="0"/>
-                <a:ea typeface="Montserrat" pitchFamily="34" charset="-122"/>
-                <a:cs typeface="Montserrat" pitchFamily="34" charset="-120"/>
-              </a:rPr>
-              <a:t>IIT DELHI</a:t>
-            </a:r>
-            <a:endParaRPr lang="en-US" sz="1400" dirty="0"/>
-          </a:p>
-        </p:txBody>
-      </p:sp>
-      <p:sp>
-        <p:nvSpPr>
-          <p:cNvPr id="7" name="Text 5"/>
-          <p:cNvSpPr txBox="1"/>
-          <p:nvPr/>
-        </p:nvSpPr>
-        <p:spPr>
-          <a:xfrm>
-            <a:off x="502920" y="512064"/>
-            <a:ext cx="3108960" cy="237744"/>
-          </a:xfrm>
-          <a:prstGeom prst="rect">
-            <a:avLst/>
-          </a:prstGeom>
-          <a:noFill/>
-          <a:ln/>
-        </p:spPr>
-        <p:txBody>
-          <a:bodyPr wrap="square" lIns="0" tIns="0" rIns="0" bIns="0" rtlCol="0" anchor="ctr"/>
-          <a:lstStyle/>
-          <a:p>
-            <a:pPr indent="0" marL="0">
-              <a:buNone/>
-            </a:pPr>
-            <a:r>
-              <a:rPr lang="en-US" sz="1000" dirty="0">
-                <a:solidFill>
-                  <a:srgbClr val="63697A"/>
-                </a:solidFill>
-                <a:latin typeface="Montserrat" pitchFamily="34" charset="0"/>
-                <a:ea typeface="Montserrat" pitchFamily="34" charset="-122"/>
-                <a:cs typeface="Montserrat" pitchFamily="34" charset="-120"/>
-              </a:rPr>
-              <a:t>Department of Electrical Engineering</a:t>
-            </a:r>
-            <a:endParaRPr lang="en-US" sz="1000" dirty="0"/>
-          </a:p>
-        </p:txBody>
-      </p:sp>
-      <p:sp>
-        <p:nvSpPr>
-          <p:cNvPr id="8" name="Shape 6"/>
+        </p:spPr>
+      </p:pic>
+      <p:sp>
+        <p:nvSpPr>
+          <p:cNvPr id="7" name="Shape 4"/>
           <p:cNvSpPr/>
           <p:nvPr/>
         </p:nvSpPr>
@@ -16666,7 +16750,7 @@
       </p:sp>
       <p:sp>
         <p:nvSpPr>
-          <p:cNvPr id="9" name="Text 7"/>
+          <p:cNvPr id="8" name="Text 5"/>
           <p:cNvSpPr txBox="1"/>
           <p:nvPr/>
         </p:nvSpPr>
@@ -16705,7 +16789,7 @@
       </p:sp>
       <p:sp>
         <p:nvSpPr>
-          <p:cNvPr id="10" name="Text 8"/>
+          <p:cNvPr id="9" name="Text 6"/>
           <p:cNvSpPr txBox="1"/>
           <p:nvPr/>
         </p:nvSpPr>
@@ -16882,9 +16966,33 @@
           </a:ln>
         </p:spPr>
       </p:sp>
-      <p:sp>
-        <p:nvSpPr>
-          <p:cNvPr id="6" name="Text 4"/>
+      <p:pic>
+        <p:nvPicPr>
+          <p:cNvPr id="6" name="Image 0" descr="D:\SEM7\BTP\docs\IITD-_logo.png">    </p:cNvPr>
+          <p:cNvPicPr>
+            <a:picLocks noChangeAspect="1"/>
+          </p:cNvPicPr>
+          <p:nvPr/>
+        </p:nvPicPr>
+        <p:blipFill>
+          <a:blip r:embed="rId1"/>
+          <a:stretch>
+            <a:fillRect/>
+          </a:stretch>
+        </p:blipFill>
+        <p:spPr>
+          <a:xfrm>
+            <a:off x="10991088" y="658368"/>
+            <a:ext cx="566928" cy="566928"/>
+          </a:xfrm>
+          <a:prstGeom prst="rect">
+            <a:avLst/>
+          </a:prstGeom>
+        </p:spPr>
+      </p:pic>
+      <p:sp>
+        <p:nvSpPr>
+          <p:cNvPr id="7" name="Text 4"/>
           <p:cNvSpPr txBox="1"/>
           <p:nvPr/>
         </p:nvSpPr>
@@ -16923,7 +17031,7 @@
       </p:sp>
       <p:sp>
         <p:nvSpPr>
-          <p:cNvPr id="7" name="Shape 5"/>
+          <p:cNvPr id="8" name="Shape 5"/>
           <p:cNvSpPr/>
           <p:nvPr/>
         </p:nvSpPr>
@@ -16946,7 +17054,7 @@
       </p:sp>
       <p:sp>
         <p:nvSpPr>
-          <p:cNvPr id="8" name="Shape 6"/>
+          <p:cNvPr id="9" name="Shape 6"/>
           <p:cNvSpPr/>
           <p:nvPr/>
         </p:nvSpPr>
@@ -16971,7 +17079,7 @@
       </p:sp>
       <p:sp>
         <p:nvSpPr>
-          <p:cNvPr id="9" name="Shape 7"/>
+          <p:cNvPr id="10" name="Shape 7"/>
           <p:cNvSpPr/>
           <p:nvPr/>
         </p:nvSpPr>
@@ -16996,7 +17104,7 @@
       </p:sp>
       <p:sp>
         <p:nvSpPr>
-          <p:cNvPr id="10" name="Text 8"/>
+          <p:cNvPr id="11" name="Text 8"/>
           <p:cNvSpPr txBox="1"/>
           <p:nvPr/>
         </p:nvSpPr>
@@ -17035,7 +17143,7 @@
       </p:sp>
       <p:sp>
         <p:nvSpPr>
-          <p:cNvPr id="11" name="Text 9"/>
+          <p:cNvPr id="12" name="Text 9"/>
           <p:cNvSpPr txBox="1"/>
           <p:nvPr/>
         </p:nvSpPr>
@@ -17153,7 +17261,7 @@
       </p:sp>
       <p:sp>
         <p:nvSpPr>
-          <p:cNvPr id="12" name="Shape 10"/>
+          <p:cNvPr id="13" name="Shape 10"/>
           <p:cNvSpPr/>
           <p:nvPr/>
         </p:nvSpPr>
@@ -17180,7 +17288,7 @@
       </p:sp>
       <p:sp>
         <p:nvSpPr>
-          <p:cNvPr id="13" name="Text 11"/>
+          <p:cNvPr id="14" name="Text 11"/>
           <p:cNvSpPr txBox="1"/>
           <p:nvPr/>
         </p:nvSpPr>
@@ -17219,7 +17327,7 @@
       </p:sp>
       <p:sp>
         <p:nvSpPr>
-          <p:cNvPr id="14" name="Shape 12"/>
+          <p:cNvPr id="15" name="Shape 12"/>
           <p:cNvSpPr/>
           <p:nvPr/>
         </p:nvSpPr>
@@ -17246,7 +17354,7 @@
       </p:sp>
       <p:sp>
         <p:nvSpPr>
-          <p:cNvPr id="15" name="Text 13"/>
+          <p:cNvPr id="16" name="Text 13"/>
           <p:cNvSpPr txBox="1"/>
           <p:nvPr/>
         </p:nvSpPr>
@@ -17285,7 +17393,7 @@
       </p:sp>
       <p:sp>
         <p:nvSpPr>
-          <p:cNvPr id="16" name="Shape 14"/>
+          <p:cNvPr id="17" name="Shape 14"/>
           <p:cNvSpPr/>
           <p:nvPr/>
         </p:nvSpPr>
@@ -17310,7 +17418,7 @@
       </p:sp>
       <p:sp>
         <p:nvSpPr>
-          <p:cNvPr id="17" name="Text 15"/>
+          <p:cNvPr id="18" name="Text 15"/>
           <p:cNvSpPr txBox="1"/>
           <p:nvPr/>
         </p:nvSpPr>
@@ -17349,7 +17457,7 @@
       </p:sp>
       <p:sp>
         <p:nvSpPr>
-          <p:cNvPr id="18" name="Text 16"/>
+          <p:cNvPr id="19" name="Text 16"/>
           <p:cNvSpPr txBox="1"/>
           <p:nvPr/>
         </p:nvSpPr>
@@ -17388,7 +17496,7 @@
       </p:sp>
       <p:sp>
         <p:nvSpPr>
-          <p:cNvPr id="19" name="Text 17"/>
+          <p:cNvPr id="20" name="Text 17"/>
           <p:cNvSpPr txBox="1"/>
           <p:nvPr/>
         </p:nvSpPr>
@@ -17427,7 +17535,7 @@
       </p:sp>
       <p:sp>
         <p:nvSpPr>
-          <p:cNvPr id="20" name="Text 18"/>
+          <p:cNvPr id="21" name="Text 18"/>
           <p:cNvSpPr txBox="1"/>
           <p:nvPr/>
         </p:nvSpPr>
@@ -17466,7 +17574,7 @@
       </p:sp>
       <p:sp>
         <p:nvSpPr>
-          <p:cNvPr id="21" name="Shape 19"/>
+          <p:cNvPr id="22" name="Shape 19"/>
           <p:cNvSpPr/>
           <p:nvPr/>
         </p:nvSpPr>
@@ -17489,7 +17597,7 @@
       </p:sp>
       <p:sp>
         <p:nvSpPr>
-          <p:cNvPr id="22" name="Shape 20"/>
+          <p:cNvPr id="23" name="Shape 20"/>
           <p:cNvSpPr/>
           <p:nvPr/>
         </p:nvSpPr>
@@ -17514,7 +17622,7 @@
       </p:sp>
       <p:sp>
         <p:nvSpPr>
-          <p:cNvPr id="23" name="Text 21"/>
+          <p:cNvPr id="24" name="Text 21"/>
           <p:cNvSpPr txBox="1"/>
           <p:nvPr/>
         </p:nvSpPr>
@@ -17553,7 +17661,7 @@
       </p:sp>
       <p:sp>
         <p:nvSpPr>
-          <p:cNvPr id="24" name="Text 22"/>
+          <p:cNvPr id="25" name="Text 22"/>
           <p:cNvSpPr txBox="1"/>
           <p:nvPr/>
         </p:nvSpPr>
@@ -17592,7 +17700,7 @@
       </p:sp>
       <p:sp>
         <p:nvSpPr>
-          <p:cNvPr id="25" name="Text 23"/>
+          <p:cNvPr id="26" name="Text 23"/>
           <p:cNvSpPr txBox="1"/>
           <p:nvPr/>
         </p:nvSpPr>
@@ -17631,7 +17739,7 @@
       </p:sp>
       <p:sp>
         <p:nvSpPr>
-          <p:cNvPr id="26" name="Text 24"/>
+          <p:cNvPr id="27" name="Text 24"/>
           <p:cNvSpPr txBox="1"/>
           <p:nvPr/>
         </p:nvSpPr>
@@ -17670,7 +17778,7 @@
       </p:sp>
       <p:sp>
         <p:nvSpPr>
-          <p:cNvPr id="27" name="Shape 25"/>
+          <p:cNvPr id="28" name="Shape 25"/>
           <p:cNvSpPr/>
           <p:nvPr/>
         </p:nvSpPr>
@@ -17693,7 +17801,7 @@
       </p:sp>
       <p:sp>
         <p:nvSpPr>
-          <p:cNvPr id="28" name="Shape 26"/>
+          <p:cNvPr id="29" name="Shape 26"/>
           <p:cNvSpPr/>
           <p:nvPr/>
         </p:nvSpPr>
@@ -17718,7 +17826,7 @@
       </p:sp>
       <p:sp>
         <p:nvSpPr>
-          <p:cNvPr id="29" name="Text 27"/>
+          <p:cNvPr id="30" name="Text 27"/>
           <p:cNvSpPr txBox="1"/>
           <p:nvPr/>
         </p:nvSpPr>
@@ -17757,7 +17865,7 @@
       </p:sp>
       <p:sp>
         <p:nvSpPr>
-          <p:cNvPr id="30" name="Text 28"/>
+          <p:cNvPr id="31" name="Text 28"/>
           <p:cNvSpPr txBox="1"/>
           <p:nvPr/>
         </p:nvSpPr>
@@ -17796,7 +17904,7 @@
       </p:sp>
       <p:sp>
         <p:nvSpPr>
-          <p:cNvPr id="31" name="Text 29"/>
+          <p:cNvPr id="32" name="Text 29"/>
           <p:cNvSpPr txBox="1"/>
           <p:nvPr/>
         </p:nvSpPr>
@@ -17835,7 +17943,7 @@
       </p:sp>
       <p:sp>
         <p:nvSpPr>
-          <p:cNvPr id="32" name="Text 30"/>
+          <p:cNvPr id="33" name="Text 30"/>
           <p:cNvSpPr txBox="1"/>
           <p:nvPr/>
         </p:nvSpPr>
@@ -18012,9 +18120,33 @@
           </a:ln>
         </p:spPr>
       </p:sp>
-      <p:sp>
-        <p:nvSpPr>
-          <p:cNvPr id="6" name="Text 4"/>
+      <p:pic>
+        <p:nvPicPr>
+          <p:cNvPr id="6" name="Image 0" descr="D:\SEM7\BTP\docs\IITD-_logo.png">    </p:cNvPr>
+          <p:cNvPicPr>
+            <a:picLocks noChangeAspect="1"/>
+          </p:cNvPicPr>
+          <p:nvPr/>
+        </p:nvPicPr>
+        <p:blipFill>
+          <a:blip r:embed="rId1"/>
+          <a:stretch>
+            <a:fillRect/>
+          </a:stretch>
+        </p:blipFill>
+        <p:spPr>
+          <a:xfrm>
+            <a:off x="10991088" y="658368"/>
+            <a:ext cx="566928" cy="566928"/>
+          </a:xfrm>
+          <a:prstGeom prst="rect">
+            <a:avLst/>
+          </a:prstGeom>
+        </p:spPr>
+      </p:pic>
+      <p:sp>
+        <p:nvSpPr>
+          <p:cNvPr id="7" name="Text 4"/>
           <p:cNvSpPr txBox="1"/>
           <p:nvPr/>
         </p:nvSpPr>
@@ -18053,7 +18185,7 @@
       </p:sp>
       <p:sp>
         <p:nvSpPr>
-          <p:cNvPr id="7" name="Shape 5"/>
+          <p:cNvPr id="8" name="Shape 5"/>
           <p:cNvSpPr/>
           <p:nvPr/>
         </p:nvSpPr>
@@ -18076,7 +18208,7 @@
       </p:sp>
       <p:sp>
         <p:nvSpPr>
-          <p:cNvPr id="8" name="Shape 6"/>
+          <p:cNvPr id="9" name="Shape 6"/>
           <p:cNvSpPr/>
           <p:nvPr/>
         </p:nvSpPr>
@@ -18101,7 +18233,7 @@
       </p:sp>
       <p:sp>
         <p:nvSpPr>
-          <p:cNvPr id="9" name="Shape 7"/>
+          <p:cNvPr id="10" name="Shape 7"/>
           <p:cNvSpPr/>
           <p:nvPr/>
         </p:nvSpPr>
@@ -18126,7 +18258,7 @@
       </p:sp>
       <p:sp>
         <p:nvSpPr>
-          <p:cNvPr id="10" name="Text 8"/>
+          <p:cNvPr id="11" name="Text 8"/>
           <p:cNvSpPr txBox="1"/>
           <p:nvPr/>
         </p:nvSpPr>
@@ -18165,7 +18297,7 @@
       </p:sp>
       <p:sp>
         <p:nvSpPr>
-          <p:cNvPr id="11" name="Text 9"/>
+          <p:cNvPr id="12" name="Text 9"/>
           <p:cNvSpPr txBox="1"/>
           <p:nvPr/>
         </p:nvSpPr>
@@ -18283,7 +18415,7 @@
       </p:sp>
       <p:sp>
         <p:nvSpPr>
-          <p:cNvPr id="12" name="Text 10"/>
+          <p:cNvPr id="13" name="Text 10"/>
           <p:cNvSpPr txBox="1"/>
           <p:nvPr/>
         </p:nvSpPr>
@@ -18322,7 +18454,7 @@
       </p:sp>
       <p:sp>
         <p:nvSpPr>
-          <p:cNvPr id="13" name="Text 11"/>
+          <p:cNvPr id="14" name="Text 11"/>
           <p:cNvSpPr txBox="1"/>
           <p:nvPr/>
         </p:nvSpPr>
@@ -18364,7 +18496,7 @@
       </p:sp>
       <p:sp>
         <p:nvSpPr>
-          <p:cNvPr id="14" name="Shape 12"/>
+          <p:cNvPr id="15" name="Shape 12"/>
           <p:cNvSpPr/>
           <p:nvPr/>
         </p:nvSpPr>
@@ -18391,7 +18523,7 @@
       </p:sp>
       <p:sp>
         <p:nvSpPr>
-          <p:cNvPr id="15" name="Text 13"/>
+          <p:cNvPr id="16" name="Text 13"/>
           <p:cNvSpPr txBox="1"/>
           <p:nvPr/>
         </p:nvSpPr>
@@ -18430,7 +18562,7 @@
       </p:sp>
       <p:sp>
         <p:nvSpPr>
-          <p:cNvPr id="16" name="Text 14"/>
+          <p:cNvPr id="17" name="Text 14"/>
           <p:cNvSpPr txBox="1"/>
           <p:nvPr/>
         </p:nvSpPr>
@@ -18469,7 +18601,7 @@
       </p:sp>
       <p:sp>
         <p:nvSpPr>
-          <p:cNvPr id="17" name="Text 15"/>
+          <p:cNvPr id="18" name="Text 15"/>
           <p:cNvSpPr txBox="1"/>
           <p:nvPr/>
         </p:nvSpPr>
@@ -18508,7 +18640,7 @@
       </p:sp>
       <p:sp>
         <p:nvSpPr>
-          <p:cNvPr id="18" name="Shape 16"/>
+          <p:cNvPr id="19" name="Shape 16"/>
           <p:cNvSpPr/>
           <p:nvPr/>
         </p:nvSpPr>
@@ -18535,7 +18667,7 @@
       </p:sp>
       <p:sp>
         <p:nvSpPr>
-          <p:cNvPr id="19" name="Text 17"/>
+          <p:cNvPr id="20" name="Text 17"/>
           <p:cNvSpPr txBox="1"/>
           <p:nvPr/>
         </p:nvSpPr>
@@ -18574,7 +18706,7 @@
       </p:sp>
       <p:sp>
         <p:nvSpPr>
-          <p:cNvPr id="20" name="Text 18"/>
+          <p:cNvPr id="21" name="Text 18"/>
           <p:cNvSpPr txBox="1"/>
           <p:nvPr/>
         </p:nvSpPr>
@@ -18613,7 +18745,7 @@
       </p:sp>
       <p:sp>
         <p:nvSpPr>
-          <p:cNvPr id="21" name="Shape 19"/>
+          <p:cNvPr id="22" name="Shape 19"/>
           <p:cNvSpPr/>
           <p:nvPr/>
         </p:nvSpPr>
@@ -18640,7 +18772,7 @@
       </p:sp>
       <p:sp>
         <p:nvSpPr>
-          <p:cNvPr id="22" name="Text 20"/>
+          <p:cNvPr id="23" name="Text 20"/>
           <p:cNvSpPr txBox="1"/>
           <p:nvPr/>
         </p:nvSpPr>
@@ -18679,7 +18811,7 @@
       </p:sp>
       <p:sp>
         <p:nvSpPr>
-          <p:cNvPr id="23" name="Text 21"/>
+          <p:cNvPr id="24" name="Text 21"/>
           <p:cNvSpPr txBox="1"/>
           <p:nvPr/>
         </p:nvSpPr>
@@ -18718,7 +18850,7 @@
       </p:sp>
       <p:sp>
         <p:nvSpPr>
-          <p:cNvPr id="24" name="Shape 22"/>
+          <p:cNvPr id="25" name="Shape 22"/>
           <p:cNvSpPr/>
           <p:nvPr/>
         </p:nvSpPr>
@@ -18745,7 +18877,7 @@
       </p:sp>
       <p:sp>
         <p:nvSpPr>
-          <p:cNvPr id="25" name="Text 23"/>
+          <p:cNvPr id="26" name="Text 23"/>
           <p:cNvSpPr txBox="1"/>
           <p:nvPr/>
         </p:nvSpPr>
@@ -18784,7 +18916,7 @@
       </p:sp>
       <p:sp>
         <p:nvSpPr>
-          <p:cNvPr id="26" name="Text 24"/>
+          <p:cNvPr id="27" name="Text 24"/>
           <p:cNvSpPr txBox="1"/>
           <p:nvPr/>
         </p:nvSpPr>
@@ -18823,7 +18955,7 @@
       </p:sp>
       <p:sp>
         <p:nvSpPr>
-          <p:cNvPr id="27" name="Shape 25"/>
+          <p:cNvPr id="28" name="Shape 25"/>
           <p:cNvSpPr/>
           <p:nvPr/>
         </p:nvSpPr>
@@ -18850,7 +18982,7 @@
       </p:sp>
       <p:sp>
         <p:nvSpPr>
-          <p:cNvPr id="28" name="Text 26"/>
+          <p:cNvPr id="29" name="Text 26"/>
           <p:cNvSpPr txBox="1"/>
           <p:nvPr/>
         </p:nvSpPr>
@@ -18889,7 +19021,7 @@
       </p:sp>
       <p:sp>
         <p:nvSpPr>
-          <p:cNvPr id="29" name="Text 27"/>
+          <p:cNvPr id="30" name="Text 27"/>
           <p:cNvSpPr txBox="1"/>
           <p:nvPr/>
         </p:nvSpPr>
@@ -18928,7 +19060,7 @@
       </p:sp>
       <p:sp>
         <p:nvSpPr>
-          <p:cNvPr id="30" name="Shape 28"/>
+          <p:cNvPr id="31" name="Shape 28"/>
           <p:cNvSpPr/>
           <p:nvPr/>
         </p:nvSpPr>
@@ -18955,7 +19087,7 @@
       </p:sp>
       <p:sp>
         <p:nvSpPr>
-          <p:cNvPr id="31" name="Text 29"/>
+          <p:cNvPr id="32" name="Text 29"/>
           <p:cNvSpPr txBox="1"/>
           <p:nvPr/>
         </p:nvSpPr>
@@ -18994,7 +19126,7 @@
       </p:sp>
       <p:sp>
         <p:nvSpPr>
-          <p:cNvPr id="32" name="Text 30"/>
+          <p:cNvPr id="33" name="Text 30"/>
           <p:cNvSpPr txBox="1"/>
           <p:nvPr/>
         </p:nvSpPr>
@@ -19171,9 +19303,33 @@
           </a:ln>
         </p:spPr>
       </p:sp>
-      <p:sp>
-        <p:nvSpPr>
-          <p:cNvPr id="6" name="Text 4"/>
+      <p:pic>
+        <p:nvPicPr>
+          <p:cNvPr id="6" name="Image 0" descr="D:\SEM7\BTP\docs\IITD-_logo.png">    </p:cNvPr>
+          <p:cNvPicPr>
+            <a:picLocks noChangeAspect="1"/>
+          </p:cNvPicPr>
+          <p:nvPr/>
+        </p:nvPicPr>
+        <p:blipFill>
+          <a:blip r:embed="rId1"/>
+          <a:stretch>
+            <a:fillRect/>
+          </a:stretch>
+        </p:blipFill>
+        <p:spPr>
+          <a:xfrm>
+            <a:off x="10991088" y="658368"/>
+            <a:ext cx="566928" cy="566928"/>
+          </a:xfrm>
+          <a:prstGeom prst="rect">
+            <a:avLst/>
+          </a:prstGeom>
+        </p:spPr>
+      </p:pic>
+      <p:sp>
+        <p:nvSpPr>
+          <p:cNvPr id="7" name="Text 4"/>
           <p:cNvSpPr txBox="1"/>
           <p:nvPr/>
         </p:nvSpPr>
@@ -19212,7 +19368,7 @@
       </p:sp>
       <p:sp>
         <p:nvSpPr>
-          <p:cNvPr id="7" name="Shape 5"/>
+          <p:cNvPr id="8" name="Shape 5"/>
           <p:cNvSpPr/>
           <p:nvPr/>
         </p:nvSpPr>
@@ -19235,7 +19391,7 @@
       </p:sp>
       <p:sp>
         <p:nvSpPr>
-          <p:cNvPr id="8" name="Shape 6"/>
+          <p:cNvPr id="9" name="Shape 6"/>
           <p:cNvSpPr/>
           <p:nvPr/>
         </p:nvSpPr>
@@ -19260,7 +19416,7 @@
       </p:sp>
       <p:sp>
         <p:nvSpPr>
-          <p:cNvPr id="9" name="Shape 7"/>
+          <p:cNvPr id="10" name="Shape 7"/>
           <p:cNvSpPr/>
           <p:nvPr/>
         </p:nvSpPr>
@@ -19285,7 +19441,7 @@
       </p:sp>
       <p:sp>
         <p:nvSpPr>
-          <p:cNvPr id="10" name="Text 8"/>
+          <p:cNvPr id="11" name="Text 8"/>
           <p:cNvSpPr txBox="1"/>
           <p:nvPr/>
         </p:nvSpPr>
@@ -19324,7 +19480,7 @@
       </p:sp>
       <p:sp>
         <p:nvSpPr>
-          <p:cNvPr id="11" name="Text 9"/>
+          <p:cNvPr id="12" name="Text 9"/>
           <p:cNvSpPr txBox="1"/>
           <p:nvPr/>
         </p:nvSpPr>
@@ -19363,7 +19519,7 @@
       </p:sp>
       <p:sp>
         <p:nvSpPr>
-          <p:cNvPr id="12" name="Text 10"/>
+          <p:cNvPr id="13" name="Text 10"/>
           <p:cNvSpPr txBox="1"/>
           <p:nvPr/>
         </p:nvSpPr>
@@ -19481,7 +19637,7 @@
       </p:sp>
       <p:sp>
         <p:nvSpPr>
-          <p:cNvPr id="13" name="Shape 11"/>
+          <p:cNvPr id="14" name="Shape 11"/>
           <p:cNvSpPr/>
           <p:nvPr/>
         </p:nvSpPr>
@@ -19508,7 +19664,7 @@
       </p:sp>
       <p:sp>
         <p:nvSpPr>
-          <p:cNvPr id="14" name="Text 12"/>
+          <p:cNvPr id="15" name="Text 12"/>
           <p:cNvSpPr txBox="1"/>
           <p:nvPr/>
         </p:nvSpPr>
@@ -19547,7 +19703,7 @@
       </p:sp>
       <p:sp>
         <p:nvSpPr>
-          <p:cNvPr id="15" name="Shape 13"/>
+          <p:cNvPr id="16" name="Shape 13"/>
           <p:cNvSpPr/>
           <p:nvPr/>
         </p:nvSpPr>
@@ -19572,7 +19728,7 @@
       </p:sp>
       <p:sp>
         <p:nvSpPr>
-          <p:cNvPr id="16" name="Shape 14"/>
+          <p:cNvPr id="17" name="Shape 14"/>
           <p:cNvSpPr/>
           <p:nvPr/>
         </p:nvSpPr>
@@ -19595,7 +19751,7 @@
       </p:sp>
       <p:sp>
         <p:nvSpPr>
-          <p:cNvPr id="17" name="Shape 15"/>
+          <p:cNvPr id="18" name="Shape 15"/>
           <p:cNvSpPr/>
           <p:nvPr/>
         </p:nvSpPr>
@@ -19620,7 +19776,7 @@
       </p:sp>
       <p:sp>
         <p:nvSpPr>
-          <p:cNvPr id="18" name="Shape 16"/>
+          <p:cNvPr id="19" name="Shape 16"/>
           <p:cNvSpPr/>
           <p:nvPr/>
         </p:nvSpPr>
@@ -19643,7 +19799,7 @@
       </p:sp>
       <p:sp>
         <p:nvSpPr>
-          <p:cNvPr id="19" name="Shape 17"/>
+          <p:cNvPr id="20" name="Shape 17"/>
           <p:cNvSpPr/>
           <p:nvPr/>
         </p:nvSpPr>
@@ -19668,7 +19824,7 @@
       </p:sp>
       <p:sp>
         <p:nvSpPr>
-          <p:cNvPr id="20" name="Shape 18"/>
+          <p:cNvPr id="21" name="Shape 18"/>
           <p:cNvSpPr/>
           <p:nvPr/>
         </p:nvSpPr>
@@ -19691,7 +19847,7 @@
       </p:sp>
       <p:sp>
         <p:nvSpPr>
-          <p:cNvPr id="21" name="Shape 19"/>
+          <p:cNvPr id="22" name="Shape 19"/>
           <p:cNvSpPr/>
           <p:nvPr/>
         </p:nvSpPr>
@@ -19716,7 +19872,7 @@
       </p:sp>
       <p:sp>
         <p:nvSpPr>
-          <p:cNvPr id="22" name="Shape 20"/>
+          <p:cNvPr id="23" name="Shape 20"/>
           <p:cNvSpPr/>
           <p:nvPr/>
         </p:nvSpPr>
@@ -19739,7 +19895,7 @@
       </p:sp>
       <p:sp>
         <p:nvSpPr>
-          <p:cNvPr id="23" name="Shape 21"/>
+          <p:cNvPr id="24" name="Shape 21"/>
           <p:cNvSpPr/>
           <p:nvPr/>
         </p:nvSpPr>
@@ -19764,7 +19920,7 @@
       </p:sp>
       <p:sp>
         <p:nvSpPr>
-          <p:cNvPr id="24" name="Text 22"/>
+          <p:cNvPr id="25" name="Text 22"/>
           <p:cNvSpPr txBox="1"/>
           <p:nvPr/>
         </p:nvSpPr>
@@ -19803,7 +19959,7 @@
       </p:sp>
       <p:sp>
         <p:nvSpPr>
-          <p:cNvPr id="25" name="Text 23"/>
+          <p:cNvPr id="26" name="Text 23"/>
           <p:cNvSpPr txBox="1"/>
           <p:nvPr/>
         </p:nvSpPr>
@@ -19842,7 +19998,7 @@
       </p:sp>
       <p:sp>
         <p:nvSpPr>
-          <p:cNvPr id="26" name="Text 24"/>
+          <p:cNvPr id="27" name="Text 24"/>
           <p:cNvSpPr txBox="1"/>
           <p:nvPr/>
         </p:nvSpPr>
@@ -19881,7 +20037,7 @@
       </p:sp>
       <p:sp>
         <p:nvSpPr>
-          <p:cNvPr id="27" name="Text 25"/>
+          <p:cNvPr id="28" name="Text 25"/>
           <p:cNvSpPr txBox="1"/>
           <p:nvPr/>
         </p:nvSpPr>
@@ -19920,7 +20076,7 @@
       </p:sp>
       <p:sp>
         <p:nvSpPr>
-          <p:cNvPr id="28" name="Text 26"/>
+          <p:cNvPr id="29" name="Text 26"/>
           <p:cNvSpPr txBox="1"/>
           <p:nvPr/>
         </p:nvSpPr>
@@ -19959,7 +20115,7 @@
       </p:sp>
       <p:sp>
         <p:nvSpPr>
-          <p:cNvPr id="29" name="Text 27"/>
+          <p:cNvPr id="30" name="Text 27"/>
           <p:cNvSpPr txBox="1"/>
           <p:nvPr/>
         </p:nvSpPr>
@@ -19998,7 +20154,7 @@
       </p:sp>
       <p:sp>
         <p:nvSpPr>
-          <p:cNvPr id="30" name="Text 28"/>
+          <p:cNvPr id="31" name="Text 28"/>
           <p:cNvSpPr txBox="1"/>
           <p:nvPr/>
         </p:nvSpPr>
@@ -20175,9 +20331,33 @@
           </a:ln>
         </p:spPr>
       </p:sp>
-      <p:sp>
-        <p:nvSpPr>
-          <p:cNvPr id="6" name="Text 4"/>
+      <p:pic>
+        <p:nvPicPr>
+          <p:cNvPr id="6" name="Image 0" descr="D:\SEM7\BTP\docs\IITD-_logo.png">    </p:cNvPr>
+          <p:cNvPicPr>
+            <a:picLocks noChangeAspect="1"/>
+          </p:cNvPicPr>
+          <p:nvPr/>
+        </p:nvPicPr>
+        <p:blipFill>
+          <a:blip r:embed="rId1"/>
+          <a:stretch>
+            <a:fillRect/>
+          </a:stretch>
+        </p:blipFill>
+        <p:spPr>
+          <a:xfrm>
+            <a:off x="10991088" y="658368"/>
+            <a:ext cx="566928" cy="566928"/>
+          </a:xfrm>
+          <a:prstGeom prst="rect">
+            <a:avLst/>
+          </a:prstGeom>
+        </p:spPr>
+      </p:pic>
+      <p:sp>
+        <p:nvSpPr>
+          <p:cNvPr id="7" name="Text 4"/>
           <p:cNvSpPr txBox="1"/>
           <p:nvPr/>
         </p:nvSpPr>
@@ -20216,7 +20396,7 @@
       </p:sp>
       <p:sp>
         <p:nvSpPr>
-          <p:cNvPr id="7" name="Shape 5"/>
+          <p:cNvPr id="8" name="Shape 5"/>
           <p:cNvSpPr/>
           <p:nvPr/>
         </p:nvSpPr>
@@ -20239,7 +20419,7 @@
       </p:sp>
       <p:sp>
         <p:nvSpPr>
-          <p:cNvPr id="8" name="Shape 6"/>
+          <p:cNvPr id="9" name="Shape 6"/>
           <p:cNvSpPr/>
           <p:nvPr/>
         </p:nvSpPr>
@@ -20264,7 +20444,7 @@
       </p:sp>
       <p:sp>
         <p:nvSpPr>
-          <p:cNvPr id="9" name="Shape 7"/>
+          <p:cNvPr id="10" name="Shape 7"/>
           <p:cNvSpPr/>
           <p:nvPr/>
         </p:nvSpPr>
@@ -20289,7 +20469,7 @@
       </p:sp>
       <p:sp>
         <p:nvSpPr>
-          <p:cNvPr id="10" name="Text 8"/>
+          <p:cNvPr id="11" name="Text 8"/>
           <p:cNvSpPr txBox="1"/>
           <p:nvPr/>
         </p:nvSpPr>
@@ -20328,7 +20508,7 @@
       </p:sp>
       <p:sp>
         <p:nvSpPr>
-          <p:cNvPr id="11" name="Text 9"/>
+          <p:cNvPr id="12" name="Text 9"/>
           <p:cNvSpPr txBox="1"/>
           <p:nvPr/>
         </p:nvSpPr>
@@ -20367,7 +20547,7 @@
       </p:sp>
       <p:sp>
         <p:nvSpPr>
-          <p:cNvPr id="12" name="Text 10"/>
+          <p:cNvPr id="13" name="Text 10"/>
           <p:cNvSpPr txBox="1"/>
           <p:nvPr/>
         </p:nvSpPr>
@@ -20485,7 +20665,7 @@
       </p:sp>
       <p:sp>
         <p:nvSpPr>
-          <p:cNvPr id="13" name="Shape 11"/>
+          <p:cNvPr id="14" name="Shape 11"/>
           <p:cNvSpPr/>
           <p:nvPr/>
         </p:nvSpPr>
@@ -20512,7 +20692,7 @@
       </p:sp>
       <p:sp>
         <p:nvSpPr>
-          <p:cNvPr id="14" name="Text 12"/>
+          <p:cNvPr id="15" name="Text 12"/>
           <p:cNvSpPr txBox="1"/>
           <p:nvPr/>
         </p:nvSpPr>
@@ -20551,7 +20731,7 @@
       </p:sp>
       <p:sp>
         <p:nvSpPr>
-          <p:cNvPr id="15" name="Shape 13"/>
+          <p:cNvPr id="16" name="Shape 13"/>
           <p:cNvSpPr/>
           <p:nvPr/>
         </p:nvSpPr>
@@ -20576,7 +20756,7 @@
       </p:sp>
       <p:sp>
         <p:nvSpPr>
-          <p:cNvPr id="16" name="Shape 14"/>
+          <p:cNvPr id="17" name="Shape 14"/>
           <p:cNvSpPr/>
           <p:nvPr/>
         </p:nvSpPr>
@@ -20599,7 +20779,7 @@
       </p:sp>
       <p:sp>
         <p:nvSpPr>
-          <p:cNvPr id="17" name="Shape 15"/>
+          <p:cNvPr id="18" name="Shape 15"/>
           <p:cNvSpPr/>
           <p:nvPr/>
         </p:nvSpPr>
@@ -20624,7 +20804,7 @@
       </p:sp>
       <p:sp>
         <p:nvSpPr>
-          <p:cNvPr id="18" name="Shape 16"/>
+          <p:cNvPr id="19" name="Shape 16"/>
           <p:cNvSpPr/>
           <p:nvPr/>
         </p:nvSpPr>
@@ -20647,7 +20827,7 @@
       </p:sp>
       <p:sp>
         <p:nvSpPr>
-          <p:cNvPr id="19" name="Shape 17"/>
+          <p:cNvPr id="20" name="Shape 17"/>
           <p:cNvSpPr/>
           <p:nvPr/>
         </p:nvSpPr>
@@ -20672,7 +20852,7 @@
       </p:sp>
       <p:sp>
         <p:nvSpPr>
-          <p:cNvPr id="20" name="Shape 18"/>
+          <p:cNvPr id="21" name="Shape 18"/>
           <p:cNvSpPr/>
           <p:nvPr/>
         </p:nvSpPr>
@@ -20695,7 +20875,7 @@
       </p:sp>
       <p:sp>
         <p:nvSpPr>
-          <p:cNvPr id="21" name="Shape 19"/>
+          <p:cNvPr id="22" name="Shape 19"/>
           <p:cNvSpPr/>
           <p:nvPr/>
         </p:nvSpPr>
@@ -20720,7 +20900,7 @@
       </p:sp>
       <p:sp>
         <p:nvSpPr>
-          <p:cNvPr id="22" name="Shape 20"/>
+          <p:cNvPr id="23" name="Shape 20"/>
           <p:cNvSpPr/>
           <p:nvPr/>
         </p:nvSpPr>
@@ -20743,7 +20923,7 @@
       </p:sp>
       <p:sp>
         <p:nvSpPr>
-          <p:cNvPr id="23" name="Shape 21"/>
+          <p:cNvPr id="24" name="Shape 21"/>
           <p:cNvSpPr/>
           <p:nvPr/>
         </p:nvSpPr>
@@ -20768,7 +20948,7 @@
       </p:sp>
       <p:sp>
         <p:nvSpPr>
-          <p:cNvPr id="24" name="Shape 22"/>
+          <p:cNvPr id="25" name="Shape 22"/>
           <p:cNvSpPr/>
           <p:nvPr/>
         </p:nvSpPr>
@@ -20791,7 +20971,7 @@
       </p:sp>
       <p:sp>
         <p:nvSpPr>
-          <p:cNvPr id="25" name="Shape 23"/>
+          <p:cNvPr id="26" name="Shape 23"/>
           <p:cNvSpPr/>
           <p:nvPr/>
         </p:nvSpPr>
@@ -20816,7 +20996,7 @@
       </p:sp>
       <p:sp>
         <p:nvSpPr>
-          <p:cNvPr id="26" name="Shape 24"/>
+          <p:cNvPr id="27" name="Shape 24"/>
           <p:cNvSpPr/>
           <p:nvPr/>
         </p:nvSpPr>
@@ -20839,7 +21019,7 @@
       </p:sp>
       <p:sp>
         <p:nvSpPr>
-          <p:cNvPr id="27" name="Shape 25"/>
+          <p:cNvPr id="28" name="Shape 25"/>
           <p:cNvSpPr/>
           <p:nvPr/>
         </p:nvSpPr>
@@ -20864,7 +21044,7 @@
       </p:sp>
       <p:sp>
         <p:nvSpPr>
-          <p:cNvPr id="28" name="Shape 26"/>
+          <p:cNvPr id="29" name="Shape 26"/>
           <p:cNvSpPr/>
           <p:nvPr/>
         </p:nvSpPr>
@@ -20887,7 +21067,7 @@
       </p:sp>
       <p:sp>
         <p:nvSpPr>
-          <p:cNvPr id="29" name="Shape 27"/>
+          <p:cNvPr id="30" name="Shape 27"/>
           <p:cNvSpPr/>
           <p:nvPr/>
         </p:nvSpPr>
@@ -20912,7 +21092,7 @@
       </p:sp>
       <p:sp>
         <p:nvSpPr>
-          <p:cNvPr id="30" name="Shape 28"/>
+          <p:cNvPr id="31" name="Shape 28"/>
           <p:cNvSpPr/>
           <p:nvPr/>
         </p:nvSpPr>
@@ -20935,7 +21115,7 @@
       </p:sp>
       <p:sp>
         <p:nvSpPr>
-          <p:cNvPr id="31" name="Shape 29"/>
+          <p:cNvPr id="32" name="Shape 29"/>
           <p:cNvSpPr/>
           <p:nvPr/>
         </p:nvSpPr>
@@ -20960,7 +21140,7 @@
       </p:sp>
       <p:sp>
         <p:nvSpPr>
-          <p:cNvPr id="32" name="Shape 30"/>
+          <p:cNvPr id="33" name="Shape 30"/>
           <p:cNvSpPr/>
           <p:nvPr/>
         </p:nvSpPr>
@@ -20983,7 +21163,7 @@
       </p:sp>
       <p:sp>
         <p:nvSpPr>
-          <p:cNvPr id="33" name="Shape 31"/>
+          <p:cNvPr id="34" name="Shape 31"/>
           <p:cNvSpPr/>
           <p:nvPr/>
         </p:nvSpPr>
@@ -21008,7 +21188,7 @@
       </p:sp>
       <p:sp>
         <p:nvSpPr>
-          <p:cNvPr id="34" name="Text 32"/>
+          <p:cNvPr id="35" name="Text 32"/>
           <p:cNvSpPr txBox="1"/>
           <p:nvPr/>
         </p:nvSpPr>
@@ -21047,7 +21227,7 @@
       </p:sp>
       <p:sp>
         <p:nvSpPr>
-          <p:cNvPr id="35" name="Text 33"/>
+          <p:cNvPr id="36" name="Text 33"/>
           <p:cNvSpPr txBox="1"/>
           <p:nvPr/>
         </p:nvSpPr>
@@ -21224,9 +21404,33 @@
           </a:ln>
         </p:spPr>
       </p:sp>
-      <p:sp>
-        <p:nvSpPr>
-          <p:cNvPr id="6" name="Text 4"/>
+      <p:pic>
+        <p:nvPicPr>
+          <p:cNvPr id="6" name="Image 0" descr="D:\SEM7\BTP\docs\IITD-_logo.png">    </p:cNvPr>
+          <p:cNvPicPr>
+            <a:picLocks noChangeAspect="1"/>
+          </p:cNvPicPr>
+          <p:nvPr/>
+        </p:nvPicPr>
+        <p:blipFill>
+          <a:blip r:embed="rId1"/>
+          <a:stretch>
+            <a:fillRect/>
+          </a:stretch>
+        </p:blipFill>
+        <p:spPr>
+          <a:xfrm>
+            <a:off x="10991088" y="658368"/>
+            <a:ext cx="566928" cy="566928"/>
+          </a:xfrm>
+          <a:prstGeom prst="rect">
+            <a:avLst/>
+          </a:prstGeom>
+        </p:spPr>
+      </p:pic>
+      <p:sp>
+        <p:nvSpPr>
+          <p:cNvPr id="7" name="Text 4"/>
           <p:cNvSpPr txBox="1"/>
           <p:nvPr/>
         </p:nvSpPr>
@@ -21265,7 +21469,7 @@
       </p:sp>
       <p:sp>
         <p:nvSpPr>
-          <p:cNvPr id="7" name="Shape 5"/>
+          <p:cNvPr id="8" name="Shape 5"/>
           <p:cNvSpPr/>
           <p:nvPr/>
         </p:nvSpPr>
@@ -21288,7 +21492,7 @@
       </p:sp>
       <p:sp>
         <p:nvSpPr>
-          <p:cNvPr id="8" name="Shape 6"/>
+          <p:cNvPr id="9" name="Shape 6"/>
           <p:cNvSpPr/>
           <p:nvPr/>
         </p:nvSpPr>
@@ -21313,7 +21517,7 @@
       </p:sp>
       <p:sp>
         <p:nvSpPr>
-          <p:cNvPr id="9" name="Shape 7"/>
+          <p:cNvPr id="10" name="Shape 7"/>
           <p:cNvSpPr/>
           <p:nvPr/>
         </p:nvSpPr>
@@ -21338,7 +21542,7 @@
       </p:sp>
       <p:sp>
         <p:nvSpPr>
-          <p:cNvPr id="10" name="Text 8"/>
+          <p:cNvPr id="11" name="Text 8"/>
           <p:cNvSpPr txBox="1"/>
           <p:nvPr/>
         </p:nvSpPr>
@@ -21377,7 +21581,7 @@
       </p:sp>
       <p:sp>
         <p:nvSpPr>
-          <p:cNvPr id="11" name="Text 9"/>
+          <p:cNvPr id="12" name="Text 9"/>
           <p:cNvSpPr txBox="1"/>
           <p:nvPr/>
         </p:nvSpPr>
@@ -21416,7 +21620,7 @@
       </p:sp>
       <p:sp>
         <p:nvSpPr>
-          <p:cNvPr id="12" name="Text 10"/>
+          <p:cNvPr id="13" name="Text 10"/>
           <p:cNvSpPr txBox="1"/>
           <p:nvPr/>
         </p:nvSpPr>
@@ -21534,7 +21738,7 @@
       </p:sp>
       <p:sp>
         <p:nvSpPr>
-          <p:cNvPr id="13" name="Shape 11"/>
+          <p:cNvPr id="14" name="Shape 11"/>
           <p:cNvSpPr/>
           <p:nvPr/>
         </p:nvSpPr>
@@ -21561,7 +21765,7 @@
       </p:sp>
       <p:sp>
         <p:nvSpPr>
-          <p:cNvPr id="14" name="Text 12"/>
+          <p:cNvPr id="15" name="Text 12"/>
           <p:cNvSpPr txBox="1"/>
           <p:nvPr/>
         </p:nvSpPr>
@@ -21600,7 +21804,7 @@
       </p:sp>
       <p:sp>
         <p:nvSpPr>
-          <p:cNvPr id="15" name="Shape 13"/>
+          <p:cNvPr id="16" name="Shape 13"/>
           <p:cNvSpPr/>
           <p:nvPr/>
         </p:nvSpPr>
@@ -21623,7 +21827,7 @@
       </p:sp>
       <p:sp>
         <p:nvSpPr>
-          <p:cNvPr id="16" name="Shape 14"/>
+          <p:cNvPr id="17" name="Shape 14"/>
           <p:cNvSpPr/>
           <p:nvPr/>
         </p:nvSpPr>
@@ -21646,7 +21850,7 @@
       </p:sp>
       <p:sp>
         <p:nvSpPr>
-          <p:cNvPr id="17" name="Shape 15"/>
+          <p:cNvPr id="18" name="Shape 15"/>
           <p:cNvSpPr/>
           <p:nvPr/>
         </p:nvSpPr>
@@ -21669,7 +21873,7 @@
       </p:sp>
       <p:sp>
         <p:nvSpPr>
-          <p:cNvPr id="18" name="Shape 16"/>
+          <p:cNvPr id="19" name="Shape 16"/>
           <p:cNvSpPr/>
           <p:nvPr/>
         </p:nvSpPr>
@@ -21692,7 +21896,7 @@
       </p:sp>
       <p:sp>
         <p:nvSpPr>
-          <p:cNvPr id="19" name="Shape 17"/>
+          <p:cNvPr id="20" name="Shape 17"/>
           <p:cNvSpPr/>
           <p:nvPr/>
         </p:nvSpPr>
@@ -21715,7 +21919,7 @@
       </p:sp>
       <p:sp>
         <p:nvSpPr>
-          <p:cNvPr id="20" name="Shape 18"/>
+          <p:cNvPr id="21" name="Shape 18"/>
           <p:cNvSpPr/>
           <p:nvPr/>
         </p:nvSpPr>
@@ -21738,7 +21942,7 @@
       </p:sp>
       <p:sp>
         <p:nvSpPr>
-          <p:cNvPr id="21" name="Shape 19"/>
+          <p:cNvPr id="22" name="Shape 19"/>
           <p:cNvSpPr/>
           <p:nvPr/>
         </p:nvSpPr>
@@ -21761,7 +21965,7 @@
       </p:sp>
       <p:sp>
         <p:nvSpPr>
-          <p:cNvPr id="22" name="Shape 20"/>
+          <p:cNvPr id="23" name="Shape 20"/>
           <p:cNvSpPr/>
           <p:nvPr/>
         </p:nvSpPr>
@@ -21784,7 +21988,7 @@
       </p:sp>
       <p:sp>
         <p:nvSpPr>
-          <p:cNvPr id="23" name="Shape 21"/>
+          <p:cNvPr id="24" name="Shape 21"/>
           <p:cNvSpPr/>
           <p:nvPr/>
         </p:nvSpPr>
@@ -21807,7 +22011,7 @@
       </p:sp>
       <p:sp>
         <p:nvSpPr>
-          <p:cNvPr id="24" name="Shape 22"/>
+          <p:cNvPr id="25" name="Shape 22"/>
           <p:cNvSpPr/>
           <p:nvPr/>
         </p:nvSpPr>
@@ -21830,7 +22034,7 @@
       </p:sp>
       <p:sp>
         <p:nvSpPr>
-          <p:cNvPr id="25" name="Shape 23"/>
+          <p:cNvPr id="26" name="Shape 23"/>
           <p:cNvSpPr/>
           <p:nvPr/>
         </p:nvSpPr>
@@ -21855,7 +22059,7 @@
       </p:sp>
       <p:sp>
         <p:nvSpPr>
-          <p:cNvPr id="26" name="Shape 24"/>
+          <p:cNvPr id="27" name="Shape 24"/>
           <p:cNvSpPr/>
           <p:nvPr/>
         </p:nvSpPr>
@@ -21880,7 +22084,7 @@
       </p:sp>
       <p:sp>
         <p:nvSpPr>
-          <p:cNvPr id="27" name="Shape 25"/>
+          <p:cNvPr id="28" name="Shape 25"/>
           <p:cNvSpPr/>
           <p:nvPr/>
         </p:nvSpPr>
@@ -21905,7 +22109,7 @@
       </p:sp>
       <p:sp>
         <p:nvSpPr>
-          <p:cNvPr id="28" name="Shape 26"/>
+          <p:cNvPr id="29" name="Shape 26"/>
           <p:cNvSpPr/>
           <p:nvPr/>
         </p:nvSpPr>
@@ -21930,7 +22134,7 @@
       </p:sp>
       <p:sp>
         <p:nvSpPr>
-          <p:cNvPr id="29" name="Shape 27"/>
+          <p:cNvPr id="30" name="Shape 27"/>
           <p:cNvSpPr/>
           <p:nvPr/>
         </p:nvSpPr>
@@ -21955,7 +22159,7 @@
       </p:sp>
       <p:sp>
         <p:nvSpPr>
-          <p:cNvPr id="30" name="Shape 28"/>
+          <p:cNvPr id="31" name="Shape 28"/>
           <p:cNvSpPr/>
           <p:nvPr/>
         </p:nvSpPr>
@@ -21980,7 +22184,7 @@
       </p:sp>
       <p:sp>
         <p:nvSpPr>
-          <p:cNvPr id="31" name="Shape 29"/>
+          <p:cNvPr id="32" name="Shape 29"/>
           <p:cNvSpPr/>
           <p:nvPr/>
         </p:nvSpPr>
@@ -22005,7 +22209,7 @@
       </p:sp>
       <p:sp>
         <p:nvSpPr>
-          <p:cNvPr id="32" name="Shape 30"/>
+          <p:cNvPr id="33" name="Shape 30"/>
           <p:cNvSpPr/>
           <p:nvPr/>
         </p:nvSpPr>
@@ -22030,7 +22234,7 @@
       </p:sp>
       <p:sp>
         <p:nvSpPr>
-          <p:cNvPr id="33" name="Text 31"/>
+          <p:cNvPr id="34" name="Text 31"/>
           <p:cNvSpPr txBox="1"/>
           <p:nvPr/>
         </p:nvSpPr>
@@ -22069,7 +22273,7 @@
       </p:sp>
       <p:sp>
         <p:nvSpPr>
-          <p:cNvPr id="34" name="Text 32"/>
+          <p:cNvPr id="35" name="Text 32"/>
           <p:cNvSpPr txBox="1"/>
           <p:nvPr/>
         </p:nvSpPr>
@@ -22246,9 +22450,33 @@
           </a:ln>
         </p:spPr>
       </p:sp>
-      <p:sp>
-        <p:nvSpPr>
-          <p:cNvPr id="6" name="Text 4"/>
+      <p:pic>
+        <p:nvPicPr>
+          <p:cNvPr id="6" name="Image 0" descr="D:\SEM7\BTP\docs\IITD-_logo.png">    </p:cNvPr>
+          <p:cNvPicPr>
+            <a:picLocks noChangeAspect="1"/>
+          </p:cNvPicPr>
+          <p:nvPr/>
+        </p:nvPicPr>
+        <p:blipFill>
+          <a:blip r:embed="rId1"/>
+          <a:stretch>
+            <a:fillRect/>
+          </a:stretch>
+        </p:blipFill>
+        <p:spPr>
+          <a:xfrm>
+            <a:off x="10991088" y="658368"/>
+            <a:ext cx="566928" cy="566928"/>
+          </a:xfrm>
+          <a:prstGeom prst="rect">
+            <a:avLst/>
+          </a:prstGeom>
+        </p:spPr>
+      </p:pic>
+      <p:sp>
+        <p:nvSpPr>
+          <p:cNvPr id="7" name="Text 4"/>
           <p:cNvSpPr txBox="1"/>
           <p:nvPr/>
         </p:nvSpPr>
@@ -22287,7 +22515,7 @@
       </p:sp>
       <p:sp>
         <p:nvSpPr>
-          <p:cNvPr id="7" name="Shape 5"/>
+          <p:cNvPr id="8" name="Shape 5"/>
           <p:cNvSpPr/>
           <p:nvPr/>
         </p:nvSpPr>
@@ -22310,7 +22538,7 @@
       </p:sp>
       <p:sp>
         <p:nvSpPr>
-          <p:cNvPr id="8" name="Shape 6"/>
+          <p:cNvPr id="9" name="Shape 6"/>
           <p:cNvSpPr/>
           <p:nvPr/>
         </p:nvSpPr>
@@ -22335,7 +22563,7 @@
       </p:sp>
       <p:sp>
         <p:nvSpPr>
-          <p:cNvPr id="9" name="Shape 7"/>
+          <p:cNvPr id="10" name="Shape 7"/>
           <p:cNvSpPr/>
           <p:nvPr/>
         </p:nvSpPr>
@@ -22360,7 +22588,7 @@
       </p:sp>
       <p:sp>
         <p:nvSpPr>
-          <p:cNvPr id="10" name="Text 8"/>
+          <p:cNvPr id="11" name="Text 8"/>
           <p:cNvSpPr txBox="1"/>
           <p:nvPr/>
         </p:nvSpPr>
@@ -22399,7 +22627,7 @@
       </p:sp>
       <p:sp>
         <p:nvSpPr>
-          <p:cNvPr id="11" name="Text 9"/>
+          <p:cNvPr id="12" name="Text 9"/>
           <p:cNvSpPr txBox="1"/>
           <p:nvPr/>
         </p:nvSpPr>
@@ -23499,7 +23727,7 @@
       </p:graphicFrame>
       <p:sp>
         <p:nvSpPr>
-          <p:cNvPr id="13" name="Text 10"/>
+          <p:cNvPr id="14" name="Text 10"/>
           <p:cNvSpPr txBox="1"/>
           <p:nvPr/>
         </p:nvSpPr>
@@ -23593,7 +23821,7 @@
       </p:sp>
       <p:sp>
         <p:nvSpPr>
-          <p:cNvPr id="14" name="Shape 11"/>
+          <p:cNvPr id="15" name="Shape 11"/>
           <p:cNvSpPr/>
           <p:nvPr/>
         </p:nvSpPr>
@@ -23620,7 +23848,7 @@
       </p:sp>
       <p:sp>
         <p:nvSpPr>
-          <p:cNvPr id="15" name="Text 12"/>
+          <p:cNvPr id="16" name="Text 12"/>
           <p:cNvSpPr txBox="1"/>
           <p:nvPr/>
         </p:nvSpPr>
@@ -23659,7 +23887,7 @@
       </p:sp>
       <p:sp>
         <p:nvSpPr>
-          <p:cNvPr id="16" name="Text 13"/>
+          <p:cNvPr id="17" name="Text 13"/>
           <p:cNvSpPr txBox="1"/>
           <p:nvPr/>
         </p:nvSpPr>
@@ -23698,7 +23926,7 @@
       </p:sp>
       <p:sp>
         <p:nvSpPr>
-          <p:cNvPr id="17" name="Shape 14"/>
+          <p:cNvPr id="18" name="Shape 14"/>
           <p:cNvSpPr/>
           <p:nvPr/>
         </p:nvSpPr>
@@ -23721,7 +23949,7 @@
       </p:sp>
       <p:sp>
         <p:nvSpPr>
-          <p:cNvPr id="18" name="Shape 15"/>
+          <p:cNvPr id="19" name="Shape 15"/>
           <p:cNvSpPr/>
           <p:nvPr/>
         </p:nvSpPr>
@@ -23744,7 +23972,7 @@
       </p:sp>
       <p:sp>
         <p:nvSpPr>
-          <p:cNvPr id="19" name="Text 16"/>
+          <p:cNvPr id="20" name="Text 16"/>
           <p:cNvSpPr txBox="1"/>
           <p:nvPr/>
         </p:nvSpPr>
@@ -23800,7 +24028,7 @@
       </p:sp>
       <p:sp>
         <p:nvSpPr>
-          <p:cNvPr id="20" name="Text 17"/>
+          <p:cNvPr id="21" name="Text 17"/>
           <p:cNvSpPr txBox="1"/>
           <p:nvPr/>
         </p:nvSpPr>
@@ -23856,7 +24084,7 @@
       </p:sp>
       <p:sp>
         <p:nvSpPr>
-          <p:cNvPr id="21" name="Text 18"/>
+          <p:cNvPr id="22" name="Text 18"/>
           <p:cNvSpPr txBox="1"/>
           <p:nvPr/>
         </p:nvSpPr>
@@ -23895,7 +24123,7 @@
       </p:sp>
       <p:sp>
         <p:nvSpPr>
-          <p:cNvPr id="22" name="Text 19"/>
+          <p:cNvPr id="23" name="Text 19"/>
           <p:cNvSpPr txBox="1"/>
           <p:nvPr/>
         </p:nvSpPr>
@@ -24072,9 +24300,33 @@
           </a:ln>
         </p:spPr>
       </p:sp>
-      <p:sp>
-        <p:nvSpPr>
-          <p:cNvPr id="6" name="Text 4"/>
+      <p:pic>
+        <p:nvPicPr>
+          <p:cNvPr id="6" name="Image 0" descr="D:\SEM7\BTP\docs\IITD-_logo.png">    </p:cNvPr>
+          <p:cNvPicPr>
+            <a:picLocks noChangeAspect="1"/>
+          </p:cNvPicPr>
+          <p:nvPr/>
+        </p:nvPicPr>
+        <p:blipFill>
+          <a:blip r:embed="rId1"/>
+          <a:stretch>
+            <a:fillRect/>
+          </a:stretch>
+        </p:blipFill>
+        <p:spPr>
+          <a:xfrm>
+            <a:off x="10991088" y="658368"/>
+            <a:ext cx="566928" cy="566928"/>
+          </a:xfrm>
+          <a:prstGeom prst="rect">
+            <a:avLst/>
+          </a:prstGeom>
+        </p:spPr>
+      </p:pic>
+      <p:sp>
+        <p:nvSpPr>
+          <p:cNvPr id="7" name="Text 4"/>
           <p:cNvSpPr txBox="1"/>
           <p:nvPr/>
         </p:nvSpPr>
@@ -24113,7 +24365,7 @@
       </p:sp>
       <p:sp>
         <p:nvSpPr>
-          <p:cNvPr id="7" name="Shape 5"/>
+          <p:cNvPr id="8" name="Shape 5"/>
           <p:cNvSpPr/>
           <p:nvPr/>
         </p:nvSpPr>
@@ -24136,7 +24388,7 @@
       </p:sp>
       <p:sp>
         <p:nvSpPr>
-          <p:cNvPr id="8" name="Shape 6"/>
+          <p:cNvPr id="9" name="Shape 6"/>
           <p:cNvSpPr/>
           <p:nvPr/>
         </p:nvSpPr>
@@ -24161,7 +24413,7 @@
       </p:sp>
       <p:sp>
         <p:nvSpPr>
-          <p:cNvPr id="9" name="Shape 7"/>
+          <p:cNvPr id="10" name="Shape 7"/>
           <p:cNvSpPr/>
           <p:nvPr/>
         </p:nvSpPr>
@@ -24186,7 +24438,7 @@
       </p:sp>
       <p:sp>
         <p:nvSpPr>
-          <p:cNvPr id="10" name="Text 8"/>
+          <p:cNvPr id="11" name="Text 8"/>
           <p:cNvSpPr txBox="1"/>
           <p:nvPr/>
         </p:nvSpPr>
@@ -24352,7 +24604,7 @@
       </p:sp>
       <p:sp>
         <p:nvSpPr>
-          <p:cNvPr id="11" name="Shape 9"/>
+          <p:cNvPr id="12" name="Shape 9"/>
           <p:cNvSpPr/>
           <p:nvPr/>
         </p:nvSpPr>
@@ -24379,7 +24631,7 @@
       </p:sp>
       <p:sp>
         <p:nvSpPr>
-          <p:cNvPr id="12" name="Text 10"/>
+          <p:cNvPr id="13" name="Text 10"/>
           <p:cNvSpPr txBox="1"/>
           <p:nvPr/>
         </p:nvSpPr>
@@ -24418,7 +24670,7 @@
       </p:sp>
       <p:sp>
         <p:nvSpPr>
-          <p:cNvPr id="13" name="Shape 11"/>
+          <p:cNvPr id="14" name="Shape 11"/>
           <p:cNvSpPr/>
           <p:nvPr/>
         </p:nvSpPr>
@@ -24443,7 +24695,7 @@
       </p:sp>
       <p:sp>
         <p:nvSpPr>
-          <p:cNvPr id="14" name="Text 12"/>
+          <p:cNvPr id="15" name="Text 12"/>
           <p:cNvSpPr txBox="1"/>
           <p:nvPr/>
         </p:nvSpPr>
@@ -24482,7 +24734,7 @@
       </p:sp>
       <p:sp>
         <p:nvSpPr>
-          <p:cNvPr id="15" name="Text 13"/>
+          <p:cNvPr id="16" name="Text 13"/>
           <p:cNvSpPr txBox="1"/>
           <p:nvPr/>
         </p:nvSpPr>
@@ -24521,7 +24773,7 @@
       </p:sp>
       <p:sp>
         <p:nvSpPr>
-          <p:cNvPr id="16" name="Shape 14"/>
+          <p:cNvPr id="17" name="Shape 14"/>
           <p:cNvSpPr/>
           <p:nvPr/>
         </p:nvSpPr>
@@ -24546,7 +24798,7 @@
       </p:sp>
       <p:sp>
         <p:nvSpPr>
-          <p:cNvPr id="17" name="Text 15"/>
+          <p:cNvPr id="18" name="Text 15"/>
           <p:cNvSpPr txBox="1"/>
           <p:nvPr/>
         </p:nvSpPr>
@@ -24585,7 +24837,7 @@
       </p:sp>
       <p:sp>
         <p:nvSpPr>
-          <p:cNvPr id="18" name="Text 16"/>
+          <p:cNvPr id="19" name="Text 16"/>
           <p:cNvSpPr txBox="1"/>
           <p:nvPr/>
         </p:nvSpPr>
@@ -24624,7 +24876,7 @@
       </p:sp>
       <p:sp>
         <p:nvSpPr>
-          <p:cNvPr id="19" name="Shape 17"/>
+          <p:cNvPr id="20" name="Shape 17"/>
           <p:cNvSpPr/>
           <p:nvPr/>
         </p:nvSpPr>
@@ -24649,7 +24901,7 @@
       </p:sp>
       <p:sp>
         <p:nvSpPr>
-          <p:cNvPr id="20" name="Text 18"/>
+          <p:cNvPr id="21" name="Text 18"/>
           <p:cNvSpPr txBox="1"/>
           <p:nvPr/>
         </p:nvSpPr>
@@ -24688,7 +24940,7 @@
       </p:sp>
       <p:sp>
         <p:nvSpPr>
-          <p:cNvPr id="21" name="Text 19"/>
+          <p:cNvPr id="22" name="Text 19"/>
           <p:cNvSpPr txBox="1"/>
           <p:nvPr/>
         </p:nvSpPr>
@@ -24727,7 +24979,7 @@
       </p:sp>
       <p:sp>
         <p:nvSpPr>
-          <p:cNvPr id="22" name="Shape 20"/>
+          <p:cNvPr id="23" name="Shape 20"/>
           <p:cNvSpPr/>
           <p:nvPr/>
         </p:nvSpPr>
@@ -24752,7 +25004,7 @@
       </p:sp>
       <p:sp>
         <p:nvSpPr>
-          <p:cNvPr id="23" name="Text 21"/>
+          <p:cNvPr id="24" name="Text 21"/>
           <p:cNvSpPr txBox="1"/>
           <p:nvPr/>
         </p:nvSpPr>
@@ -24791,7 +25043,7 @@
       </p:sp>
       <p:sp>
         <p:nvSpPr>
-          <p:cNvPr id="24" name="Text 22"/>
+          <p:cNvPr id="25" name="Text 22"/>
           <p:cNvSpPr txBox="1"/>
           <p:nvPr/>
         </p:nvSpPr>
@@ -24830,7 +25082,7 @@
       </p:sp>
       <p:sp>
         <p:nvSpPr>
-          <p:cNvPr id="25" name="Shape 23"/>
+          <p:cNvPr id="26" name="Shape 23"/>
           <p:cNvSpPr/>
           <p:nvPr/>
         </p:nvSpPr>
@@ -24855,7 +25107,7 @@
       </p:sp>
       <p:sp>
         <p:nvSpPr>
-          <p:cNvPr id="26" name="Text 24"/>
+          <p:cNvPr id="27" name="Text 24"/>
           <p:cNvSpPr txBox="1"/>
           <p:nvPr/>
         </p:nvSpPr>
@@ -24894,7 +25146,7 @@
       </p:sp>
       <p:sp>
         <p:nvSpPr>
-          <p:cNvPr id="27" name="Text 25"/>
+          <p:cNvPr id="28" name="Text 25"/>
           <p:cNvSpPr txBox="1"/>
           <p:nvPr/>
         </p:nvSpPr>
@@ -24933,7 +25185,7 @@
       </p:sp>
       <p:sp>
         <p:nvSpPr>
-          <p:cNvPr id="28" name="Shape 26"/>
+          <p:cNvPr id="29" name="Shape 26"/>
           <p:cNvSpPr/>
           <p:nvPr/>
         </p:nvSpPr>
@@ -24958,7 +25210,7 @@
       </p:sp>
       <p:sp>
         <p:nvSpPr>
-          <p:cNvPr id="29" name="Text 27"/>
+          <p:cNvPr id="30" name="Text 27"/>
           <p:cNvSpPr txBox="1"/>
           <p:nvPr/>
         </p:nvSpPr>
@@ -24997,7 +25249,7 @@
       </p:sp>
       <p:sp>
         <p:nvSpPr>
-          <p:cNvPr id="30" name="Text 28"/>
+          <p:cNvPr id="31" name="Text 28"/>
           <p:cNvSpPr txBox="1"/>
           <p:nvPr/>
         </p:nvSpPr>
@@ -25036,7 +25288,7 @@
       </p:sp>
       <p:sp>
         <p:nvSpPr>
-          <p:cNvPr id="31" name="Shape 29"/>
+          <p:cNvPr id="32" name="Shape 29"/>
           <p:cNvSpPr/>
           <p:nvPr/>
         </p:nvSpPr>
@@ -25061,7 +25313,7 @@
       </p:sp>
       <p:sp>
         <p:nvSpPr>
-          <p:cNvPr id="32" name="Text 30"/>
+          <p:cNvPr id="33" name="Text 30"/>
           <p:cNvSpPr txBox="1"/>
           <p:nvPr/>
         </p:nvSpPr>
@@ -25100,7 +25352,7 @@
       </p:sp>
       <p:sp>
         <p:nvSpPr>
-          <p:cNvPr id="33" name="Text 31"/>
+          <p:cNvPr id="34" name="Text 31"/>
           <p:cNvSpPr txBox="1"/>
           <p:nvPr/>
         </p:nvSpPr>
@@ -25277,9 +25529,33 @@
           </a:ln>
         </p:spPr>
       </p:sp>
-      <p:sp>
-        <p:nvSpPr>
-          <p:cNvPr id="6" name="Text 4"/>
+      <p:pic>
+        <p:nvPicPr>
+          <p:cNvPr id="6" name="Image 0" descr="D:\SEM7\BTP\docs\IITD-_logo.png">    </p:cNvPr>
+          <p:cNvPicPr>
+            <a:picLocks noChangeAspect="1"/>
+          </p:cNvPicPr>
+          <p:nvPr/>
+        </p:nvPicPr>
+        <p:blipFill>
+          <a:blip r:embed="rId1"/>
+          <a:stretch>
+            <a:fillRect/>
+          </a:stretch>
+        </p:blipFill>
+        <p:spPr>
+          <a:xfrm>
+            <a:off x="10991088" y="658368"/>
+            <a:ext cx="566928" cy="566928"/>
+          </a:xfrm>
+          <a:prstGeom prst="rect">
+            <a:avLst/>
+          </a:prstGeom>
+        </p:spPr>
+      </p:pic>
+      <p:sp>
+        <p:nvSpPr>
+          <p:cNvPr id="7" name="Text 4"/>
           <p:cNvSpPr txBox="1"/>
           <p:nvPr/>
         </p:nvSpPr>
@@ -25318,7 +25594,7 @@
       </p:sp>
       <p:sp>
         <p:nvSpPr>
-          <p:cNvPr id="7" name="Shape 5"/>
+          <p:cNvPr id="8" name="Shape 5"/>
           <p:cNvSpPr/>
           <p:nvPr/>
         </p:nvSpPr>
@@ -25341,7 +25617,7 @@
       </p:sp>
       <p:sp>
         <p:nvSpPr>
-          <p:cNvPr id="8" name="Shape 6"/>
+          <p:cNvPr id="9" name="Shape 6"/>
           <p:cNvSpPr/>
           <p:nvPr/>
         </p:nvSpPr>
@@ -25366,7 +25642,7 @@
       </p:sp>
       <p:sp>
         <p:nvSpPr>
-          <p:cNvPr id="9" name="Shape 7"/>
+          <p:cNvPr id="10" name="Shape 7"/>
           <p:cNvSpPr/>
           <p:nvPr/>
         </p:nvSpPr>
@@ -25391,7 +25667,7 @@
       </p:sp>
       <p:sp>
         <p:nvSpPr>
-          <p:cNvPr id="10" name="Text 8"/>
+          <p:cNvPr id="11" name="Text 8"/>
           <p:cNvSpPr txBox="1"/>
           <p:nvPr/>
         </p:nvSpPr>
@@ -25430,7 +25706,7 @@
       </p:sp>
       <p:sp>
         <p:nvSpPr>
-          <p:cNvPr id="11" name="Shape 9"/>
+          <p:cNvPr id="12" name="Shape 9"/>
           <p:cNvSpPr/>
           <p:nvPr/>
         </p:nvSpPr>
@@ -25457,7 +25733,7 @@
       </p:sp>
       <p:sp>
         <p:nvSpPr>
-          <p:cNvPr id="12" name="Text 10"/>
+          <p:cNvPr id="13" name="Text 10"/>
           <p:cNvSpPr txBox="1"/>
           <p:nvPr/>
         </p:nvSpPr>
@@ -25496,7 +25772,7 @@
       </p:sp>
       <p:sp>
         <p:nvSpPr>
-          <p:cNvPr id="13" name="Text 11"/>
+          <p:cNvPr id="14" name="Text 11"/>
           <p:cNvSpPr txBox="1"/>
           <p:nvPr/>
         </p:nvSpPr>
@@ -26887,7 +27163,7 @@
       </p:graphicFrame>
       <p:sp>
         <p:nvSpPr>
-          <p:cNvPr id="15" name="Text 12"/>
+          <p:cNvPr id="16" name="Text 12"/>
           <p:cNvSpPr txBox="1"/>
           <p:nvPr/>
         </p:nvSpPr>
@@ -26926,7 +27202,7 @@
       </p:sp>
       <p:sp>
         <p:nvSpPr>
-          <p:cNvPr id="16" name="Text 13"/>
+          <p:cNvPr id="17" name="Text 13"/>
           <p:cNvSpPr txBox="1"/>
           <p:nvPr/>
         </p:nvSpPr>
@@ -26965,7 +27241,7 @@
       </p:sp>
       <p:sp>
         <p:nvSpPr>
-          <p:cNvPr id="17" name="Shape 14"/>
+          <p:cNvPr id="18" name="Shape 14"/>
           <p:cNvSpPr/>
           <p:nvPr/>
         </p:nvSpPr>
@@ -26992,7 +27268,7 @@
       </p:sp>
       <p:sp>
         <p:nvSpPr>
-          <p:cNvPr id="18" name="Shape 15"/>
+          <p:cNvPr id="19" name="Shape 15"/>
           <p:cNvSpPr/>
           <p:nvPr/>
         </p:nvSpPr>
@@ -27015,7 +27291,7 @@
       </p:sp>
       <p:sp>
         <p:nvSpPr>
-          <p:cNvPr id="19" name="Shape 16"/>
+          <p:cNvPr id="20" name="Shape 16"/>
           <p:cNvSpPr/>
           <p:nvPr/>
         </p:nvSpPr>
@@ -27040,7 +27316,7 @@
       </p:sp>
       <p:sp>
         <p:nvSpPr>
-          <p:cNvPr id="20" name="Shape 17"/>
+          <p:cNvPr id="21" name="Shape 17"/>
           <p:cNvSpPr/>
           <p:nvPr/>
         </p:nvSpPr>
@@ -27063,7 +27339,7 @@
       </p:sp>
       <p:sp>
         <p:nvSpPr>
-          <p:cNvPr id="21" name="Shape 18"/>
+          <p:cNvPr id="22" name="Shape 18"/>
           <p:cNvSpPr/>
           <p:nvPr/>
         </p:nvSpPr>
@@ -27088,7 +27364,7 @@
       </p:sp>
       <p:sp>
         <p:nvSpPr>
-          <p:cNvPr id="22" name="Shape 19"/>
+          <p:cNvPr id="23" name="Shape 19"/>
           <p:cNvSpPr/>
           <p:nvPr/>
         </p:nvSpPr>
@@ -27111,7 +27387,7 @@
       </p:sp>
       <p:sp>
         <p:nvSpPr>
-          <p:cNvPr id="23" name="Shape 20"/>
+          <p:cNvPr id="24" name="Shape 20"/>
           <p:cNvSpPr/>
           <p:nvPr/>
         </p:nvSpPr>
@@ -27136,7 +27412,7 @@
       </p:sp>
       <p:sp>
         <p:nvSpPr>
-          <p:cNvPr id="24" name="Shape 21"/>
+          <p:cNvPr id="25" name="Shape 21"/>
           <p:cNvSpPr/>
           <p:nvPr/>
         </p:nvSpPr>
@@ -27159,7 +27435,7 @@
       </p:sp>
       <p:sp>
         <p:nvSpPr>
-          <p:cNvPr id="25" name="Shape 22"/>
+          <p:cNvPr id="26" name="Shape 22"/>
           <p:cNvSpPr/>
           <p:nvPr/>
         </p:nvSpPr>
@@ -27184,7 +27460,7 @@
       </p:sp>
       <p:sp>
         <p:nvSpPr>
-          <p:cNvPr id="26" name="Shape 23"/>
+          <p:cNvPr id="27" name="Shape 23"/>
           <p:cNvSpPr/>
           <p:nvPr/>
         </p:nvSpPr>
@@ -27209,7 +27485,7 @@
       </p:sp>
       <p:sp>
         <p:nvSpPr>
-          <p:cNvPr id="27" name="Text 24"/>
+          <p:cNvPr id="28" name="Text 24"/>
           <p:cNvSpPr txBox="1"/>
           <p:nvPr/>
         </p:nvSpPr>
@@ -27265,7 +27541,7 @@
       </p:sp>
       <p:sp>
         <p:nvSpPr>
-          <p:cNvPr id="28" name="Shape 25"/>
+          <p:cNvPr id="29" name="Shape 25"/>
           <p:cNvSpPr/>
           <p:nvPr/>
         </p:nvSpPr>
@@ -27292,7 +27568,7 @@
       </p:sp>
       <p:sp>
         <p:nvSpPr>
-          <p:cNvPr id="29" name="Text 26"/>
+          <p:cNvPr id="30" name="Text 26"/>
           <p:cNvSpPr txBox="1"/>
           <p:nvPr/>
         </p:nvSpPr>
@@ -27331,7 +27607,7 @@
       </p:sp>
       <p:sp>
         <p:nvSpPr>
-          <p:cNvPr id="30" name="Text 27"/>
+          <p:cNvPr id="31" name="Text 27"/>
           <p:cNvSpPr txBox="1"/>
           <p:nvPr/>
         </p:nvSpPr>

</xml_diff>